<commit_message>
docs: slide di riserva con il diagramma ER completo (PRD v2.3) nella presentazione PowerPoint e PDF
Co-Authored-By: Claude Opus 5.5 <noreply@anthropic.com>
</commit_message>
<xml_diff>
--- a/docs/Presentazione_PRD_v2.1.pptx
+++ b/docs/Presentazione_PRD_v2.1.pptx
@@ -4,27 +4,31 @@
   <p:sldMasterIdLst>
     <p:sldMasterId id="2147483648" r:id="rId1"/>
   </p:sldMasterIdLst>
+  <p:notesMasterIdLst>
+    <p:notesMasterId r:id="rId21"/>
+  </p:notesMasterIdLst>
   <p:sldIdLst>
-    <p:sldId id="256" r:id="rId7"/>
-    <p:sldId id="257" r:id="rId9"/>
-    <p:sldId id="258" r:id="rId10"/>
-    <p:sldId id="259" r:id="rId11"/>
-    <p:sldId id="260" r:id="rId12"/>
-    <p:sldId id="261" r:id="rId13"/>
-    <p:sldId id="262" r:id="rId14"/>
-    <p:sldId id="263" r:id="rId15"/>
-    <p:sldId id="264" r:id="rId16"/>
-    <p:sldId id="265" r:id="rId17"/>
-    <p:sldId id="266" r:id="rId18"/>
-    <p:sldId id="267" r:id="rId19"/>
-    <p:sldId id="268" r:id="rId20"/>
-    <p:sldId id="269" r:id="rId21"/>
-    <p:sldId id="270" r:id="rId22"/>
-    <p:sldId id="271" r:id="rId23"/>
-    <p:sldId id="272" r:id="rId24"/>
-    <p:sldId id="273" r:id="rId25"/>
+    <p:sldId id="256" r:id="rId2"/>
+    <p:sldId id="257" r:id="rId3"/>
+    <p:sldId id="258" r:id="rId4"/>
+    <p:sldId id="259" r:id="rId5"/>
+    <p:sldId id="260" r:id="rId6"/>
+    <p:sldId id="261" r:id="rId7"/>
+    <p:sldId id="262" r:id="rId8"/>
+    <p:sldId id="263" r:id="rId9"/>
+    <p:sldId id="264" r:id="rId10"/>
+    <p:sldId id="265" r:id="rId11"/>
+    <p:sldId id="266" r:id="rId12"/>
+    <p:sldId id="267" r:id="rId13"/>
+    <p:sldId id="268" r:id="rId14"/>
+    <p:sldId id="269" r:id="rId15"/>
+    <p:sldId id="270" r:id="rId16"/>
+    <p:sldId id="271" r:id="rId17"/>
+    <p:sldId id="272" r:id="rId18"/>
+    <p:sldId id="273" r:id="rId19"/>
+    <p:sldId id="274" r:id="rId20"/>
   </p:sldIdLst>
-  <p:sldSz cx="12192000" cy="6858000" type="screen4x3"/>
+  <p:sldSz cx="12192000" cy="6858000"/>
   <p:notesSz cx="6858000" cy="9144000"/>
   <p:defaultTextStyle>
     <a:defPPr>
@@ -121,11 +125,27 @@
       </a:defRPr>
     </a:lvl9pPr>
   </p:defaultTextStyle>
+  <p:extLst>
+    <p:ext uri="{EFAFB233-063F-42B5-8137-9DF3F51BA10A}">
+      <p15:sldGuideLst xmlns:p15="http://schemas.microsoft.com/office/powerpoint/2012/main">
+        <p15:guide id="1" orient="horz" pos="2160">
+          <p15:clr>
+            <a:srgbClr val="A4A3A4"/>
+          </p15:clr>
+        </p15:guide>
+        <p15:guide id="2" pos="2880">
+          <p15:clr>
+            <a:srgbClr val="A4A3A4"/>
+          </p15:clr>
+        </p15:guide>
+      </p15:sldGuideLst>
+    </p:ext>
+  </p:extLst>
 </p:presentation>
 </file>
 
 <file path=ppt/notesMasters/notesMaster1.xml><?xml version="1.0" encoding="utf-8"?>
-<p:notesMaster xmlns:a="http://schemas.openxmlformats.org/drawingml/2006/main" xmlns:p="http://schemas.openxmlformats.org/presentationml/2006/main" xmlns:r="http://schemas.openxmlformats.org/officeDocument/2006/relationships">
+<p:notesMaster xmlns:a="http://schemas.openxmlformats.org/drawingml/2006/main" xmlns:r="http://schemas.openxmlformats.org/officeDocument/2006/relationships" xmlns:p="http://schemas.openxmlformats.org/presentationml/2006/main">
   <p:cSld>
     <p:bg>
       <p:bgRef idx="1001">
@@ -146,241 +166,16 @@
           <a:chExt cx="0" cy="0"/>
         </a:xfrm>
       </p:grpSpPr>
-      <p:sp>
-        <p:nvSpPr>
-          <p:cNvPr id="2" name="Header Placeholder 1"/>
-          <p:cNvSpPr>
-            <a:spLocks noGrp="1"/>
-          </p:cNvSpPr>
-          <p:nvPr>
-            <p:ph type="hdr" sz="quarter"/>
-          </p:nvPr>
-        </p:nvSpPr>
-        <p:spPr>
-          <a:xfrm>
-            <a:off x="0" y="0"/>
-            <a:ext cx="2971800" cy="457200"/>
-          </a:xfrm>
-          <a:prstGeom prst="rect">
-            <a:avLst/>
-          </a:prstGeom>
-        </p:spPr>
-        <p:txBody>
-          <a:bodyPr vert="horz" lIns="91440" tIns="45720" rIns="91440" bIns="45720" rtlCol="0"/>
-          <a:lstStyle>
-            <a:lvl1pPr algn="l">
-              <a:defRPr sz="1200"/>
-            </a:lvl1pPr>
-          </a:lstStyle>
-          <a:p>
-            <a:endParaRPr lang="en-US"/>
-          </a:p>
-        </p:txBody>
-      </p:sp>
-      <p:sp>
-        <p:nvSpPr>
-          <p:cNvPr id="3" name="Date Placeholder 2"/>
-          <p:cNvSpPr>
-            <a:spLocks noGrp="1"/>
-          </p:cNvSpPr>
-          <p:nvPr>
-            <p:ph type="dt" idx="1"/>
-          </p:nvPr>
-        </p:nvSpPr>
-        <p:spPr>
-          <a:xfrm>
-            <a:off x="3884613" y="0"/>
-            <a:ext cx="2971800" cy="457200"/>
-          </a:xfrm>
-          <a:prstGeom prst="rect">
-            <a:avLst/>
-          </a:prstGeom>
-        </p:spPr>
-        <p:txBody>
-          <a:bodyPr vert="horz" lIns="91440" tIns="45720" rIns="91440" bIns="45720" rtlCol="0"/>
-          <a:lstStyle>
-            <a:lvl1pPr algn="r">
-              <a:defRPr sz="1200"/>
-            </a:lvl1pPr>
-          </a:lstStyle>
-          <a:p>
-            <a:fld id="{0F89C1C7-3DCD-1040-A9CF-14679D8B5DDD}" type="datetimeFigureOut">
-              <a:rPr lang="en-US" smtClean="0"/>
-              <a:t>10/17/16</a:t>
-            </a:fld>
-            <a:endParaRPr lang="en-US"/>
-          </a:p>
-        </p:txBody>
-      </p:sp>
-      <p:sp>
-        <p:nvSpPr>
-          <p:cNvPr id="4" name="Slide Image Placeholder 3"/>
-          <p:cNvSpPr>
-            <a:spLocks noGrp="1" noRot="1" noChangeAspect="1"/>
-          </p:cNvSpPr>
-          <p:nvPr>
-            <p:ph type="sldImg" idx="2"/>
-          </p:nvPr>
-        </p:nvSpPr>
-        <p:spPr>
-          <a:xfrm>
-            <a:off x="1143000" y="685800"/>
-            <a:ext cx="4572000" cy="3429000"/>
-          </a:xfrm>
-          <a:prstGeom prst="rect">
-            <a:avLst/>
-          </a:prstGeom>
-          <a:noFill/>
-          <a:ln w="12700">
-            <a:solidFill>
-              <a:prstClr val="black"/>
-            </a:solidFill>
-          </a:ln>
-        </p:spPr>
-        <p:txBody>
-          <a:bodyPr vert="horz" lIns="91440" tIns="45720" rIns="91440" bIns="45720" rtlCol="0" anchor="ctr"/>
-          <a:lstStyle/>
-          <a:p>
-            <a:endParaRPr lang="en-US"/>
-          </a:p>
-        </p:txBody>
-      </p:sp>
-      <p:sp>
-        <p:nvSpPr>
-          <p:cNvPr id="5" name="Notes Placeholder 4"/>
-          <p:cNvSpPr>
-            <a:spLocks noGrp="1"/>
-          </p:cNvSpPr>
-          <p:nvPr>
-            <p:ph type="body" sz="quarter" idx="3"/>
-          </p:nvPr>
-        </p:nvSpPr>
-        <p:spPr>
-          <a:xfrm>
-            <a:off x="685800" y="4343400"/>
-            <a:ext cx="5486400" cy="4114800"/>
-          </a:xfrm>
-          <a:prstGeom prst="rect">
-            <a:avLst/>
-          </a:prstGeom>
-        </p:spPr>
-        <p:txBody>
-          <a:bodyPr vert="horz" lIns="91440" tIns="45720" rIns="91440" bIns="45720" rtlCol="0"/>
-          <a:lstStyle/>
-          <a:p>
-            <a:pPr lvl="0"/>
-            <a:r>
-              <a:rPr lang="en-US" smtClean="0"/>
-              <a:t>Click to edit Master text styles</a:t>
-            </a:r>
-          </a:p>
-          <a:p>
-            <a:pPr lvl="1"/>
-            <a:r>
-              <a:rPr lang="en-US" smtClean="0"/>
-              <a:t>Second level</a:t>
-            </a:r>
-          </a:p>
-          <a:p>
-            <a:pPr lvl="2"/>
-            <a:r>
-              <a:rPr lang="en-US" smtClean="0"/>
-              <a:t>Third level</a:t>
-            </a:r>
-          </a:p>
-          <a:p>
-            <a:pPr lvl="3"/>
-            <a:r>
-              <a:rPr lang="en-US" smtClean="0"/>
-              <a:t>Fourth level</a:t>
-            </a:r>
-          </a:p>
-          <a:p>
-            <a:pPr lvl="4"/>
-            <a:r>
-              <a:rPr lang="en-US" smtClean="0"/>
-              <a:t>Fifth level</a:t>
-            </a:r>
-            <a:endParaRPr lang="en-US"/>
-          </a:p>
-        </p:txBody>
-      </p:sp>
-      <p:sp>
-        <p:nvSpPr>
-          <p:cNvPr id="6" name="Footer Placeholder 5"/>
-          <p:cNvSpPr>
-            <a:spLocks noGrp="1"/>
-          </p:cNvSpPr>
-          <p:nvPr>
-            <p:ph type="ftr" sz="quarter" idx="4"/>
-          </p:nvPr>
-        </p:nvSpPr>
-        <p:spPr>
-          <a:xfrm>
-            <a:off x="0" y="8685213"/>
-            <a:ext cx="2971800" cy="457200"/>
-          </a:xfrm>
-          <a:prstGeom prst="rect">
-            <a:avLst/>
-          </a:prstGeom>
-        </p:spPr>
-        <p:txBody>
-          <a:bodyPr vert="horz" lIns="91440" tIns="45720" rIns="91440" bIns="45720" rtlCol="0" anchor="b"/>
-          <a:lstStyle>
-            <a:lvl1pPr algn="l">
-              <a:defRPr sz="1200"/>
-            </a:lvl1pPr>
-          </a:lstStyle>
-          <a:p>
-            <a:endParaRPr lang="en-US"/>
-          </a:p>
-        </p:txBody>
-      </p:sp>
-      <p:sp>
-        <p:nvSpPr>
-          <p:cNvPr id="7" name="Slide Number Placeholder 6"/>
-          <p:cNvSpPr>
-            <a:spLocks noGrp="1"/>
-          </p:cNvSpPr>
-          <p:nvPr>
-            <p:ph type="sldNum" sz="quarter" idx="5"/>
-          </p:nvPr>
-        </p:nvSpPr>
-        <p:spPr>
-          <a:xfrm>
-            <a:off x="3884613" y="8685213"/>
-            <a:ext cx="2971800" cy="457200"/>
-          </a:xfrm>
-          <a:prstGeom prst="rect">
-            <a:avLst/>
-          </a:prstGeom>
-        </p:spPr>
-        <p:txBody>
-          <a:bodyPr vert="horz" lIns="91440" tIns="45720" rIns="91440" bIns="45720" rtlCol="0" anchor="b"/>
-          <a:lstStyle>
-            <a:lvl1pPr algn="r">
-              <a:defRPr sz="1200"/>
-            </a:lvl1pPr>
-          </a:lstStyle>
-          <a:p>
-            <a:fld id="{BB5E49A5-4136-284D-997B-48E1D791AD67}" type="slidenum">
-              <a:rPr lang="en-US" smtClean="0"/>
-              <a:t>‹#›</a:t>
-            </a:fld>
-            <a:endParaRPr lang="en-US"/>
-          </a:p>
-        </p:txBody>
-      </p:sp>
     </p:spTree>
     <p:extLst>
       <p:ext uri="{BB962C8B-B14F-4D97-AF65-F5344CB8AC3E}">
-        <p14:creationId xmlns:p14="http://schemas.microsoft.com/office/powerpoint/2010/main" val="2623252185"/>
+        <p14:creationId xmlns:p14="http://schemas.microsoft.com/office/powerpoint/2010/main" val="257775451"/>
       </p:ext>
     </p:extLst>
   </p:cSld>
   <p:clrMap bg1="lt1" tx1="dk1" bg2="lt2" tx2="dk2" accent1="accent1" accent2="accent2" accent3="accent3" accent4="accent4" accent5="accent5" accent6="accent6" hlink="hlink" folHlink="folHlink"/>
   <p:notesStyle>
-    <a:lvl1pPr marL="0" algn="l" defTabSz="457200" rtl="0" eaLnBrk="1" latinLnBrk="0" hangingPunct="1">
+    <a:lvl1pPr marL="0" algn="l" defTabSz="914400" rtl="0" eaLnBrk="1" latinLnBrk="0" hangingPunct="1">
       <a:defRPr sz="1200" kern="1200">
         <a:solidFill>
           <a:schemeClr val="tx1"/>
@@ -390,7 +185,7 @@
         <a:cs typeface="+mn-cs"/>
       </a:defRPr>
     </a:lvl1pPr>
-    <a:lvl2pPr marL="457200" algn="l" defTabSz="457200" rtl="0" eaLnBrk="1" latinLnBrk="0" hangingPunct="1">
+    <a:lvl2pPr marL="457200" algn="l" defTabSz="914400" rtl="0" eaLnBrk="1" latinLnBrk="0" hangingPunct="1">
       <a:defRPr sz="1200" kern="1200">
         <a:solidFill>
           <a:schemeClr val="tx1"/>
@@ -400,7 +195,7 @@
         <a:cs typeface="+mn-cs"/>
       </a:defRPr>
     </a:lvl2pPr>
-    <a:lvl3pPr marL="914400" algn="l" defTabSz="457200" rtl="0" eaLnBrk="1" latinLnBrk="0" hangingPunct="1">
+    <a:lvl3pPr marL="914400" algn="l" defTabSz="914400" rtl="0" eaLnBrk="1" latinLnBrk="0" hangingPunct="1">
       <a:defRPr sz="1200" kern="1200">
         <a:solidFill>
           <a:schemeClr val="tx1"/>
@@ -410,7 +205,7 @@
         <a:cs typeface="+mn-cs"/>
       </a:defRPr>
     </a:lvl3pPr>
-    <a:lvl4pPr marL="1371600" algn="l" defTabSz="457200" rtl="0" eaLnBrk="1" latinLnBrk="0" hangingPunct="1">
+    <a:lvl4pPr marL="1371600" algn="l" defTabSz="914400" rtl="0" eaLnBrk="1" latinLnBrk="0" hangingPunct="1">
       <a:defRPr sz="1200" kern="1200">
         <a:solidFill>
           <a:schemeClr val="tx1"/>
@@ -420,7 +215,7 @@
         <a:cs typeface="+mn-cs"/>
       </a:defRPr>
     </a:lvl4pPr>
-    <a:lvl5pPr marL="1828800" algn="l" defTabSz="457200" rtl="0" eaLnBrk="1" latinLnBrk="0" hangingPunct="1">
+    <a:lvl5pPr marL="1828800" algn="l" defTabSz="914400" rtl="0" eaLnBrk="1" latinLnBrk="0" hangingPunct="1">
       <a:defRPr sz="1200" kern="1200">
         <a:solidFill>
           <a:schemeClr val="tx1"/>
@@ -430,7 +225,7 @@
         <a:cs typeface="+mn-cs"/>
       </a:defRPr>
     </a:lvl5pPr>
-    <a:lvl6pPr marL="2286000" algn="l" defTabSz="457200" rtl="0" eaLnBrk="1" latinLnBrk="0" hangingPunct="1">
+    <a:lvl6pPr marL="2286000" algn="l" defTabSz="914400" rtl="0" eaLnBrk="1" latinLnBrk="0" hangingPunct="1">
       <a:defRPr sz="1200" kern="1200">
         <a:solidFill>
           <a:schemeClr val="tx1"/>
@@ -440,7 +235,7 @@
         <a:cs typeface="+mn-cs"/>
       </a:defRPr>
     </a:lvl6pPr>
-    <a:lvl7pPr marL="2743200" algn="l" defTabSz="457200" rtl="0" eaLnBrk="1" latinLnBrk="0" hangingPunct="1">
+    <a:lvl7pPr marL="2743200" algn="l" defTabSz="914400" rtl="0" eaLnBrk="1" latinLnBrk="0" hangingPunct="1">
       <a:defRPr sz="1200" kern="1200">
         <a:solidFill>
           <a:schemeClr val="tx1"/>
@@ -450,7 +245,7 @@
         <a:cs typeface="+mn-cs"/>
       </a:defRPr>
     </a:lvl7pPr>
-    <a:lvl8pPr marL="3200400" algn="l" defTabSz="457200" rtl="0" eaLnBrk="1" latinLnBrk="0" hangingPunct="1">
+    <a:lvl8pPr marL="3200400" algn="l" defTabSz="914400" rtl="0" eaLnBrk="1" latinLnBrk="0" hangingPunct="1">
       <a:defRPr sz="1200" kern="1200">
         <a:solidFill>
           <a:schemeClr val="tx1"/>
@@ -460,7 +255,7 @@
         <a:cs typeface="+mn-cs"/>
       </a:defRPr>
     </a:lvl8pPr>
-    <a:lvl9pPr marL="3657600" algn="l" defTabSz="457200" rtl="0" eaLnBrk="1" latinLnBrk="0" hangingPunct="1">
+    <a:lvl9pPr marL="3657600" algn="l" defTabSz="914400" rtl="0" eaLnBrk="1" latinLnBrk="0" hangingPunct="1">
       <a:defRPr sz="1200" kern="1200">
         <a:solidFill>
           <a:schemeClr val="tx1"/>
@@ -475,7 +270,7 @@
 </file>
 
 <file path=ppt/notesSlides/notesSlide1.xml><?xml version="1.0" encoding="utf-8"?>
-<p:notes xmlns:a="http://schemas.openxmlformats.org/drawingml/2006/main" xmlns:p="http://schemas.openxmlformats.org/presentationml/2006/main" xmlns:r="http://schemas.openxmlformats.org/officeDocument/2006/relationships">
+<p:notes xmlns:a="http://schemas.openxmlformats.org/drawingml/2006/main" xmlns:r="http://schemas.openxmlformats.org/officeDocument/2006/relationships" xmlns:p="http://schemas.openxmlformats.org/presentationml/2006/main">
   <p:cSld>
     <p:spTree>
       <p:nvGrpSpPr>
@@ -495,7 +290,7 @@
         <p:nvSpPr>
           <p:cNvPr id="2" name="Slide Image Placeholder 1"/>
           <p:cNvSpPr>
-            <a:spLocks noGrp="1"/>
+            <a:spLocks noGrp="1" noRot="1" noChangeAspect="1"/>
           </p:cNvSpPr>
           <p:nvPr>
             <p:ph type="sldImg" idx="2"/>
@@ -510,7 +305,7 @@
             <a:spLocks noGrp="1"/>
           </p:cNvSpPr>
           <p:nvPr>
-            <p:ph type="body" idx="3" sz="quarter"/>
+            <p:ph type="body" sz="quarter" idx="3"/>
           </p:nvPr>
         </p:nvSpPr>
         <p:spPr/>
@@ -522,7 +317,9 @@
               <a:t>⏱ 20 secondi</a:t>
             </a:r>
           </a:p>
-          <a:p/>
+          <a:p>
+            <a:endParaRPr/>
+          </a:p>
           <a:p>
             <a:r>
               <a:t>Buongiorno. Mi chiamo Andrea Pavan.</a:t>
@@ -562,7 +359,7 @@
             <a:spLocks noGrp="1"/>
           </p:cNvSpPr>
           <p:nvPr>
-            <p:ph type="sldNum" idx="5" sz="quarter"/>
+            <p:ph type="sldNum" sz="quarter" idx="5"/>
           </p:nvPr>
         </p:nvSpPr>
         <p:spPr/>
@@ -576,7 +373,7 @@
 </file>
 
 <file path=ppt/notesSlides/notesSlide10.xml><?xml version="1.0" encoding="utf-8"?>
-<p:notes xmlns:a="http://schemas.openxmlformats.org/drawingml/2006/main" xmlns:p="http://schemas.openxmlformats.org/presentationml/2006/main" xmlns:r="http://schemas.openxmlformats.org/officeDocument/2006/relationships">
+<p:notes xmlns:a="http://schemas.openxmlformats.org/drawingml/2006/main" xmlns:r="http://schemas.openxmlformats.org/officeDocument/2006/relationships" xmlns:p="http://schemas.openxmlformats.org/presentationml/2006/main">
   <p:cSld>
     <p:spTree>
       <p:nvGrpSpPr>
@@ -596,7 +393,7 @@
         <p:nvSpPr>
           <p:cNvPr id="2" name="Slide Image Placeholder 1"/>
           <p:cNvSpPr>
-            <a:spLocks noGrp="1"/>
+            <a:spLocks noGrp="1" noRot="1" noChangeAspect="1"/>
           </p:cNvSpPr>
           <p:nvPr>
             <p:ph type="sldImg" idx="2"/>
@@ -611,7 +408,7 @@
             <a:spLocks noGrp="1"/>
           </p:cNvSpPr>
           <p:nvPr>
-            <p:ph type="body" idx="3" sz="quarter"/>
+            <p:ph type="body" sz="quarter" idx="3"/>
           </p:nvPr>
         </p:nvSpPr>
         <p:spPr/>
@@ -623,7 +420,9 @@
               <a:t>⏱ 45 secondi</a:t>
             </a:r>
           </a:p>
-          <a:p/>
+          <a:p>
+            <a:endParaRPr/>
+          </a:p>
           <a:p>
             <a:r>
               <a:t>Siamo ancora nei requisiti funzionali: che cosa fa il sistema?</a:t>
@@ -673,7 +472,7 @@
             <a:spLocks noGrp="1"/>
           </p:cNvSpPr>
           <p:nvPr>
-            <p:ph type="sldNum" idx="5" sz="quarter"/>
+            <p:ph type="sldNum" sz="quarter" idx="5"/>
           </p:nvPr>
         </p:nvSpPr>
         <p:spPr/>
@@ -687,7 +486,7 @@
 </file>
 
 <file path=ppt/notesSlides/notesSlide11.xml><?xml version="1.0" encoding="utf-8"?>
-<p:notes xmlns:a="http://schemas.openxmlformats.org/drawingml/2006/main" xmlns:p="http://schemas.openxmlformats.org/presentationml/2006/main" xmlns:r="http://schemas.openxmlformats.org/officeDocument/2006/relationships">
+<p:notes xmlns:a="http://schemas.openxmlformats.org/drawingml/2006/main" xmlns:r="http://schemas.openxmlformats.org/officeDocument/2006/relationships" xmlns:p="http://schemas.openxmlformats.org/presentationml/2006/main">
   <p:cSld>
     <p:spTree>
       <p:nvGrpSpPr>
@@ -707,7 +506,7 @@
         <p:nvSpPr>
           <p:cNvPr id="2" name="Slide Image Placeholder 1"/>
           <p:cNvSpPr>
-            <a:spLocks noGrp="1"/>
+            <a:spLocks noGrp="1" noRot="1" noChangeAspect="1"/>
           </p:cNvSpPr>
           <p:nvPr>
             <p:ph type="sldImg" idx="2"/>
@@ -722,7 +521,7 @@
             <a:spLocks noGrp="1"/>
           </p:cNvSpPr>
           <p:nvPr>
-            <p:ph type="body" idx="3" sz="quarter"/>
+            <p:ph type="body" sz="quarter" idx="3"/>
           </p:nvPr>
         </p:nvSpPr>
         <p:spPr/>
@@ -734,7 +533,9 @@
               <a:t>⏱ 45 secondi</a:t>
             </a:r>
           </a:p>
-          <a:p/>
+          <a:p>
+            <a:endParaRPr/>
+          </a:p>
           <a:p>
             <a:r>
               <a:t>I requisiti non funzionali rispondono a un’altra domanda: come deve funzionare il sistema, e quanto bene?</a:t>
@@ -779,7 +580,7 @@
             <a:spLocks noGrp="1"/>
           </p:cNvSpPr>
           <p:nvPr>
-            <p:ph type="sldNum" idx="5" sz="quarter"/>
+            <p:ph type="sldNum" sz="quarter" idx="5"/>
           </p:nvPr>
         </p:nvSpPr>
         <p:spPr/>
@@ -793,7 +594,7 @@
 </file>
 
 <file path=ppt/notesSlides/notesSlide12.xml><?xml version="1.0" encoding="utf-8"?>
-<p:notes xmlns:a="http://schemas.openxmlformats.org/drawingml/2006/main" xmlns:p="http://schemas.openxmlformats.org/presentationml/2006/main" xmlns:r="http://schemas.openxmlformats.org/officeDocument/2006/relationships">
+<p:notes xmlns:a="http://schemas.openxmlformats.org/drawingml/2006/main" xmlns:r="http://schemas.openxmlformats.org/officeDocument/2006/relationships" xmlns:p="http://schemas.openxmlformats.org/presentationml/2006/main">
   <p:cSld>
     <p:spTree>
       <p:nvGrpSpPr>
@@ -813,7 +614,7 @@
         <p:nvSpPr>
           <p:cNvPr id="2" name="Slide Image Placeholder 1"/>
           <p:cNvSpPr>
-            <a:spLocks noGrp="1"/>
+            <a:spLocks noGrp="1" noRot="1" noChangeAspect="1"/>
           </p:cNvSpPr>
           <p:nvPr>
             <p:ph type="sldImg" idx="2"/>
@@ -828,7 +629,7 @@
             <a:spLocks noGrp="1"/>
           </p:cNvSpPr>
           <p:nvPr>
-            <p:ph type="body" idx="3" sz="quarter"/>
+            <p:ph type="body" sz="quarter" idx="3"/>
           </p:nvPr>
         </p:nvSpPr>
         <p:spPr/>
@@ -840,7 +641,9 @@
               <a:t>⏱ 45 secondi</a:t>
             </a:r>
           </a:p>
-          <a:p/>
+          <a:p>
+            <a:endParaRPr/>
+          </a:p>
           <a:p>
             <a:r>
               <a:t>Qui separo tre cose.</a:t>
@@ -880,7 +683,7 @@
             <a:spLocks noGrp="1"/>
           </p:cNvSpPr>
           <p:nvPr>
-            <p:ph type="sldNum" idx="5" sz="quarter"/>
+            <p:ph type="sldNum" sz="quarter" idx="5"/>
           </p:nvPr>
         </p:nvSpPr>
         <p:spPr/>
@@ -894,7 +697,7 @@
 </file>
 
 <file path=ppt/notesSlides/notesSlide13.xml><?xml version="1.0" encoding="utf-8"?>
-<p:notes xmlns:a="http://schemas.openxmlformats.org/drawingml/2006/main" xmlns:p="http://schemas.openxmlformats.org/presentationml/2006/main" xmlns:r="http://schemas.openxmlformats.org/officeDocument/2006/relationships">
+<p:notes xmlns:a="http://schemas.openxmlformats.org/drawingml/2006/main" xmlns:r="http://schemas.openxmlformats.org/officeDocument/2006/relationships" xmlns:p="http://schemas.openxmlformats.org/presentationml/2006/main">
   <p:cSld>
     <p:spTree>
       <p:nvGrpSpPr>
@@ -914,7 +717,7 @@
         <p:nvSpPr>
           <p:cNvPr id="2" name="Slide Image Placeholder 1"/>
           <p:cNvSpPr>
-            <a:spLocks noGrp="1"/>
+            <a:spLocks noGrp="1" noRot="1" noChangeAspect="1"/>
           </p:cNvSpPr>
           <p:nvPr>
             <p:ph type="sldImg" idx="2"/>
@@ -929,7 +732,7 @@
             <a:spLocks noGrp="1"/>
           </p:cNvSpPr>
           <p:nvPr>
-            <p:ph type="body" idx="3" sz="quarter"/>
+            <p:ph type="body" sz="quarter" idx="3"/>
           </p:nvPr>
         </p:nvSpPr>
         <p:spPr/>
@@ -941,7 +744,9 @@
               <a:t>⏱ 30 secondi</a:t>
             </a:r>
           </a:p>
-          <a:p/>
+          <a:p>
+            <a:endParaRPr/>
+          </a:p>
           <a:p>
             <a:r>
               <a:t>Inizia la seconda parte: il come.</a:t>
@@ -971,7 +776,7 @@
             <a:spLocks noGrp="1"/>
           </p:cNvSpPr>
           <p:nvPr>
-            <p:ph type="sldNum" idx="5" sz="quarter"/>
+            <p:ph type="sldNum" sz="quarter" idx="5"/>
           </p:nvPr>
         </p:nvSpPr>
         <p:spPr/>
@@ -985,7 +790,7 @@
 </file>
 
 <file path=ppt/notesSlides/notesSlide14.xml><?xml version="1.0" encoding="utf-8"?>
-<p:notes xmlns:a="http://schemas.openxmlformats.org/drawingml/2006/main" xmlns:p="http://schemas.openxmlformats.org/presentationml/2006/main" xmlns:r="http://schemas.openxmlformats.org/officeDocument/2006/relationships">
+<p:notes xmlns:a="http://schemas.openxmlformats.org/drawingml/2006/main" xmlns:r="http://schemas.openxmlformats.org/officeDocument/2006/relationships" xmlns:p="http://schemas.openxmlformats.org/presentationml/2006/main">
   <p:cSld>
     <p:spTree>
       <p:nvGrpSpPr>
@@ -1005,7 +810,7 @@
         <p:nvSpPr>
           <p:cNvPr id="2" name="Slide Image Placeholder 1"/>
           <p:cNvSpPr>
-            <a:spLocks noGrp="1"/>
+            <a:spLocks noGrp="1" noRot="1" noChangeAspect="1"/>
           </p:cNvSpPr>
           <p:nvPr>
             <p:ph type="sldImg" idx="2"/>
@@ -1020,7 +825,7 @@
             <a:spLocks noGrp="1"/>
           </p:cNvSpPr>
           <p:nvPr>
-            <p:ph type="body" idx="3" sz="quarter"/>
+            <p:ph type="body" sz="quarter" idx="3"/>
           </p:nvPr>
         </p:nvSpPr>
         <p:spPr/>
@@ -1032,7 +837,9 @@
               <a:t>⏱ 60 secondi</a:t>
             </a:r>
           </a:p>
-          <a:p/>
+          <a:p>
+            <a:endParaRPr/>
+          </a:p>
           <a:p>
             <a:r>
               <a:t>Per ogni scelta ho scritto l’alternativa scartata e il perché. Criteri: cosa so già usare, costi, requisiti non funzionali, diffusione.</a:t>
@@ -1097,7 +904,7 @@
             <a:spLocks noGrp="1"/>
           </p:cNvSpPr>
           <p:nvPr>
-            <p:ph type="sldNum" idx="5" sz="quarter"/>
+            <p:ph type="sldNum" sz="quarter" idx="5"/>
           </p:nvPr>
         </p:nvSpPr>
         <p:spPr/>
@@ -1111,7 +918,7 @@
 </file>
 
 <file path=ppt/notesSlides/notesSlide15.xml><?xml version="1.0" encoding="utf-8"?>
-<p:notes xmlns:a="http://schemas.openxmlformats.org/drawingml/2006/main" xmlns:p="http://schemas.openxmlformats.org/presentationml/2006/main" xmlns:r="http://schemas.openxmlformats.org/officeDocument/2006/relationships">
+<p:notes xmlns:a="http://schemas.openxmlformats.org/drawingml/2006/main" xmlns:r="http://schemas.openxmlformats.org/officeDocument/2006/relationships" xmlns:p="http://schemas.openxmlformats.org/presentationml/2006/main">
   <p:cSld>
     <p:spTree>
       <p:nvGrpSpPr>
@@ -1131,7 +938,7 @@
         <p:nvSpPr>
           <p:cNvPr id="2" name="Slide Image Placeholder 1"/>
           <p:cNvSpPr>
-            <a:spLocks noGrp="1"/>
+            <a:spLocks noGrp="1" noRot="1" noChangeAspect="1"/>
           </p:cNvSpPr>
           <p:nvPr>
             <p:ph type="sldImg" idx="2"/>
@@ -1146,7 +953,7 @@
             <a:spLocks noGrp="1"/>
           </p:cNvSpPr>
           <p:nvPr>
-            <p:ph type="body" idx="3" sz="quarter"/>
+            <p:ph type="body" sz="quarter" idx="3"/>
           </p:nvPr>
         </p:nvSpPr>
         <p:spPr/>
@@ -1158,7 +965,9 @@
               <a:t>⏱ 30 secondi</a:t>
             </a:r>
           </a:p>
-          <a:p/>
+          <a:p>
+            <a:endParaRPr/>
+          </a:p>
           <a:p>
             <a:r>
               <a:t>Il gestionale sono i riquadri verdi: l’app web, l’API, il worker e il database.</a:t>
@@ -1193,7 +1002,7 @@
             <a:spLocks noGrp="1"/>
           </p:cNvSpPr>
           <p:nvPr>
-            <p:ph type="sldNum" idx="5" sz="quarter"/>
+            <p:ph type="sldNum" sz="quarter" idx="5"/>
           </p:nvPr>
         </p:nvSpPr>
         <p:spPr/>
@@ -1207,7 +1016,7 @@
 </file>
 
 <file path=ppt/notesSlides/notesSlide16.xml><?xml version="1.0" encoding="utf-8"?>
-<p:notes xmlns:a="http://schemas.openxmlformats.org/drawingml/2006/main" xmlns:p="http://schemas.openxmlformats.org/presentationml/2006/main" xmlns:r="http://schemas.openxmlformats.org/officeDocument/2006/relationships">
+<p:notes xmlns:a="http://schemas.openxmlformats.org/drawingml/2006/main" xmlns:r="http://schemas.openxmlformats.org/officeDocument/2006/relationships" xmlns:p="http://schemas.openxmlformats.org/presentationml/2006/main">
   <p:cSld>
     <p:spTree>
       <p:nvGrpSpPr>
@@ -1227,7 +1036,7 @@
         <p:nvSpPr>
           <p:cNvPr id="2" name="Slide Image Placeholder 1"/>
           <p:cNvSpPr>
-            <a:spLocks noGrp="1"/>
+            <a:spLocks noGrp="1" noRot="1" noChangeAspect="1"/>
           </p:cNvSpPr>
           <p:nvPr>
             <p:ph type="sldImg" idx="2"/>
@@ -1242,7 +1051,7 @@
             <a:spLocks noGrp="1"/>
           </p:cNvSpPr>
           <p:nvPr>
-            <p:ph type="body" idx="3" sz="quarter"/>
+            <p:ph type="body" sz="quarter" idx="3"/>
           </p:nvPr>
         </p:nvSpPr>
         <p:spPr/>
@@ -1254,7 +1063,9 @@
               <a:t>⏱ 40 secondi</a:t>
             </a:r>
           </a:p>
-          <a:p/>
+          <a:p>
+            <a:endParaRPr/>
+          </a:p>
           <a:p>
             <a:r>
               <a:t>I capitoli dall’11 al 18 sono nel PRD: API, dati, sicurezza, qualità, costi, rilascio, tempi e valutazione. Li presenterò in un secondo momento.</a:t>
@@ -1299,7 +1110,7 @@
             <a:spLocks noGrp="1"/>
           </p:cNvSpPr>
           <p:nvPr>
-            <p:ph type="sldNum" idx="5" sz="quarter"/>
+            <p:ph type="sldNum" sz="quarter" idx="5"/>
           </p:nvPr>
         </p:nvSpPr>
         <p:spPr/>
@@ -1313,7 +1124,7 @@
 </file>
 
 <file path=ppt/notesSlides/notesSlide17.xml><?xml version="1.0" encoding="utf-8"?>
-<p:notes xmlns:a="http://schemas.openxmlformats.org/drawingml/2006/main" xmlns:p="http://schemas.openxmlformats.org/presentationml/2006/main" xmlns:r="http://schemas.openxmlformats.org/officeDocument/2006/relationships">
+<p:notes xmlns:a="http://schemas.openxmlformats.org/drawingml/2006/main" xmlns:r="http://schemas.openxmlformats.org/officeDocument/2006/relationships" xmlns:p="http://schemas.openxmlformats.org/presentationml/2006/main">
   <p:cSld>
     <p:spTree>
       <p:nvGrpSpPr>
@@ -1333,7 +1144,7 @@
         <p:nvSpPr>
           <p:cNvPr id="2" name="Slide Image Placeholder 1"/>
           <p:cNvSpPr>
-            <a:spLocks noGrp="1"/>
+            <a:spLocks noGrp="1" noRot="1" noChangeAspect="1"/>
           </p:cNvSpPr>
           <p:nvPr>
             <p:ph type="sldImg" idx="2"/>
@@ -1348,7 +1159,7 @@
             <a:spLocks noGrp="1"/>
           </p:cNvSpPr>
           <p:nvPr>
-            <p:ph type="body" idx="3" sz="quarter"/>
+            <p:ph type="body" sz="quarter" idx="3"/>
           </p:nvPr>
         </p:nvSpPr>
         <p:spPr/>
@@ -1360,7 +1171,9 @@
               <a:t>⏱ 15 secondi</a:t>
             </a:r>
           </a:p>
-          <a:p/>
+          <a:p>
+            <a:endParaRPr/>
+          </a:p>
           <a:p>
             <a:r>
               <a:t>Grazie.</a:t>
@@ -1390,7 +1203,7 @@
             <a:spLocks noGrp="1"/>
           </p:cNvSpPr>
           <p:nvPr>
-            <p:ph type="sldNum" idx="5" sz="quarter"/>
+            <p:ph type="sldNum" sz="quarter" idx="5"/>
           </p:nvPr>
         </p:nvSpPr>
         <p:spPr/>
@@ -1404,7 +1217,7 @@
 </file>
 
 <file path=ppt/notesSlides/notesSlide18.xml><?xml version="1.0" encoding="utf-8"?>
-<p:notes xmlns:a="http://schemas.openxmlformats.org/drawingml/2006/main" xmlns:p="http://schemas.openxmlformats.org/presentationml/2006/main" xmlns:r="http://schemas.openxmlformats.org/officeDocument/2006/relationships">
+<p:notes xmlns:a="http://schemas.openxmlformats.org/drawingml/2006/main" xmlns:r="http://schemas.openxmlformats.org/officeDocument/2006/relationships" xmlns:p="http://schemas.openxmlformats.org/presentationml/2006/main">
   <p:cSld>
     <p:spTree>
       <p:nvGrpSpPr>
@@ -1424,7 +1237,7 @@
         <p:nvSpPr>
           <p:cNvPr id="2" name="Slide Image Placeholder 1"/>
           <p:cNvSpPr>
-            <a:spLocks noGrp="1"/>
+            <a:spLocks noGrp="1" noRot="1" noChangeAspect="1"/>
           </p:cNvSpPr>
           <p:nvPr>
             <p:ph type="sldImg" idx="2"/>
@@ -1439,7 +1252,7 @@
             <a:spLocks noGrp="1"/>
           </p:cNvSpPr>
           <p:nvPr>
-            <p:ph type="body" idx="3" sz="quarter"/>
+            <p:ph type="body" sz="quarter" idx="3"/>
           </p:nvPr>
         </p:nvSpPr>
         <p:spPr/>
@@ -1451,7 +1264,9 @@
               <a:t>Riserva: solo se chiedono dei rischi</a:t>
             </a:r>
           </a:p>
-          <a:p/>
+          <a:p>
+            <a:endParaRPr/>
+          </a:p>
           <a:p>
             <a:r>
               <a:t>Solo se il docente chiede dei rischi.</a:t>
@@ -1486,7 +1301,7 @@
             <a:spLocks noGrp="1"/>
           </p:cNvSpPr>
           <p:nvPr>
-            <p:ph type="sldNum" idx="5" sz="quarter"/>
+            <p:ph type="sldNum" sz="quarter" idx="5"/>
           </p:nvPr>
         </p:nvSpPr>
         <p:spPr/>
@@ -1499,8 +1314,8 @@
 </p:notes>
 </file>
 
-<file path=ppt/notesSlides/notesSlide2.xml><?xml version="1.0" encoding="utf-8"?>
-<p:notes xmlns:a="http://schemas.openxmlformats.org/drawingml/2006/main" xmlns:p="http://schemas.openxmlformats.org/presentationml/2006/main" xmlns:r="http://schemas.openxmlformats.org/officeDocument/2006/relationships">
+<file path=ppt/notesSlides/notesSlide19.xml><?xml version="1.0" encoding="utf-8"?>
+<p:notes xmlns:a="http://schemas.openxmlformats.org/drawingml/2006/main" xmlns:r="http://schemas.openxmlformats.org/officeDocument/2006/relationships" xmlns:p="http://schemas.openxmlformats.org/presentationml/2006/main">
   <p:cSld>
     <p:spTree>
       <p:nvGrpSpPr>
@@ -1518,81 +1333,75 @@
       </p:grpSpPr>
       <p:sp>
         <p:nvSpPr>
-          <p:cNvPr id="2" name="Slide Image Placeholder 1"/>
-          <p:cNvSpPr>
-            <a:spLocks noGrp="1"/>
-          </p:cNvSpPr>
-          <p:nvPr>
-            <p:ph type="sldImg" idx="2"/>
-          </p:nvPr>
-        </p:nvSpPr>
-        <p:spPr/>
-      </p:sp>
-      <p:sp>
-        <p:nvSpPr>
-          <p:cNvPr id="3" name="Notes Placeholder 2"/>
-          <p:cNvSpPr>
-            <a:spLocks noGrp="1"/>
-          </p:cNvSpPr>
-          <p:nvPr>
-            <p:ph type="body" idx="3" sz="quarter"/>
-          </p:nvPr>
-        </p:nvSpPr>
-        <p:spPr/>
+          <p:cNvPr id="2" name="Segnaposto immagine diapositiva 1"/>
+          <p:cNvSpPr>
+            <a:spLocks noGrp="1" noRot="1" noChangeAspect="1"/>
+          </p:cNvSpPr>
+          <p:nvPr>
+            <p:ph type="sldImg"/>
+          </p:nvPr>
+        </p:nvSpPr>
+        <p:spPr>
+          <a:xfrm>
+            <a:off x="685800" y="1143000"/>
+            <a:ext cx="5486400" cy="3086100"/>
+          </a:xfrm>
+          <a:prstGeom prst="rect">
+            <a:avLst/>
+          </a:prstGeom>
+          <a:noFill/>
+          <a:ln w="12700">
+            <a:solidFill>
+              <a:prstClr val="black"/>
+            </a:solidFill>
+          </a:ln>
+        </p:spPr>
+      </p:sp>
+      <p:sp>
+        <p:nvSpPr>
+          <p:cNvPr id="3" name="Segnaposto note 2"/>
+          <p:cNvSpPr>
+            <a:spLocks noGrp="1"/>
+          </p:cNvSpPr>
+          <p:nvPr>
+            <p:ph type="body" idx="1"/>
+          </p:nvPr>
+        </p:nvSpPr>
+        <p:spPr>
+          <a:xfrm>
+            <a:off x="685800" y="4400550"/>
+            <a:ext cx="5486400" cy="3600450"/>
+          </a:xfrm>
+          <a:prstGeom prst="rect">
+            <a:avLst/>
+          </a:prstGeom>
+        </p:spPr>
         <p:txBody>
           <a:bodyPr/>
           <a:lstStyle/>
           <a:p>
             <a:r>
-              <a:t>⏱ 40 secondi</a:t>
-            </a:r>
-          </a:p>
-          <a:p/>
-          <a:p>
-            <a:r>
-              <a:t>Prima di parlare del gestionale, due parole sull’associazione.</a:t>
-            </a:r>
-          </a:p>
-          <a:p>
-            <a:r>
-              <a:t>Effatà è nata nel 2023 per sostenere Silvia, una volontaria di Treviso che dal 2020 vive in Uganda.</a:t>
-            </a:r>
-          </a:p>
-          <a:p>
-            <a:r>
-              <a:t>Lavora in modo diretto: Silvia manda ogni giorno foto e notizie ai sostenitori su WhatsApp, e visita le famiglie.</a:t>
-            </a:r>
-          </a:p>
-          <a:p>
-            <a:r>
-              <a:t>— pausa —</a:t>
-            </a:r>
-          </a:p>
-          <a:p>
-            <a:r>
-              <a:t>I progetti: circa 1.200 bambini a scuola; per le famiglie casette, terreni, animali, materassi e scarpe; operazioni chirurgiche; e una casa famiglia che accoglie già 38 orfani.</a:t>
-            </a:r>
-          </a:p>
-          <a:p>
-            <a:r>
-              <a:t>L’obiettivo è una relazione fra chi dona e chi riceve. Il gestionale serve a renderla tracciabile.</a:t>
-            </a:r>
-          </a:p>
-        </p:txBody>
-      </p:sp>
-      <p:sp>
-        <p:nvSpPr>
-          <p:cNvPr id="4" name="Slide Number Placeholder 3"/>
-          <p:cNvSpPr>
-            <a:spLocks noGrp="1"/>
-          </p:cNvSpPr>
-          <p:nvPr>
-            <p:ph type="sldNum" idx="5" sz="quarter"/>
-          </p:nvPr>
-        </p:nvSpPr>
-        <p:spPr/>
+              <a:rPr lang="it-IT"/>
+              <a:t>Riserva: solo se chiedono del database</a:t>
+            </a:r>
+          </a:p>
+          <a:p>
+            <a:endParaRPr lang="it-IT"/>
+          </a:p>
+          <a:p>
+            <a:r>
+              <a:rPr lang="it-IT"/>
+              <a:t>Solo se il docente chiede del modello dei dati. Il database è PostgreSQL 16, relazionale, con 37 tabelle in cinque gruppi, uno per colore. Al centro ci sono la donazione e le sue quote: ogni quota va sempre a un capitolo, cioè a un progetto di VERIF!CO, e quando c'è a un intervento, a un anno di adozione o a una voce fissa in attesa di consegna. L'adozione non è un intervento: è un impegno che si rinnova ogni anno, con una riga per ogni anno pagato. Il beneficiario e i contenuti appartengono sempre a un bambino oppure a una famiglia, mai a entrambi. Il dettaglio dei campi è nei diagrammi per gruppo del capitolo 12.2.</a:t>
+            </a:r>
+          </a:p>
+        </p:txBody>
       </p:sp>
     </p:spTree>
+    <p:extLst>
+      <p:ext uri="{BB962C8B-B14F-4D97-AF65-F5344CB8AC3E}">
+        <p14:creationId xmlns:p14="http://schemas.microsoft.com/office/powerpoint/2010/main" val="4194994246"/>
+      </p:ext>
+    </p:extLst>
   </p:cSld>
   <p:clrMapOvr>
     <a:masterClrMapping/>
@@ -1600,8 +1409,8 @@
 </p:notes>
 </file>
 
-<file path=ppt/notesSlides/notesSlide3.xml><?xml version="1.0" encoding="utf-8"?>
-<p:notes xmlns:a="http://schemas.openxmlformats.org/drawingml/2006/main" xmlns:p="http://schemas.openxmlformats.org/presentationml/2006/main" xmlns:r="http://schemas.openxmlformats.org/officeDocument/2006/relationships">
+<file path=ppt/notesSlides/notesSlide2.xml><?xml version="1.0" encoding="utf-8"?>
+<p:notes xmlns:a="http://schemas.openxmlformats.org/drawingml/2006/main" xmlns:r="http://schemas.openxmlformats.org/officeDocument/2006/relationships" xmlns:p="http://schemas.openxmlformats.org/presentationml/2006/main">
   <p:cSld>
     <p:spTree>
       <p:nvGrpSpPr>
@@ -1621,7 +1430,7 @@
         <p:nvSpPr>
           <p:cNvPr id="2" name="Slide Image Placeholder 1"/>
           <p:cNvSpPr>
-            <a:spLocks noGrp="1"/>
+            <a:spLocks noGrp="1" noRot="1" noChangeAspect="1"/>
           </p:cNvSpPr>
           <p:nvPr>
             <p:ph type="sldImg" idx="2"/>
@@ -1636,7 +1445,7 @@
             <a:spLocks noGrp="1"/>
           </p:cNvSpPr>
           <p:nvPr>
-            <p:ph type="body" idx="3" sz="quarter"/>
+            <p:ph type="body" sz="quarter" idx="3"/>
           </p:nvPr>
         </p:nvSpPr>
         <p:spPr/>
@@ -1645,33 +1454,25 @@
           <a:lstStyle/>
           <a:p>
             <a:r>
-              <a:t>⏱ 45 secondi</a:t>
-            </a:r>
-          </a:p>
-          <a:p/>
-          <a:p>
-            <a:r>
-              <a:t>Effatà segue circa 700 padrini, più di mille donatori e 1.200 bambini.</a:t>
-            </a:r>
-          </a:p>
-          <a:p>
-            <a:r>
-              <a:t>Oggi ci sono tre problemi.</a:t>
-            </a:r>
-          </a:p>
-          <a:p>
-            <a:r>
-              <a:t>Primo: molti fanno il bonifico prima di registrarsi. I dati si cercano dopo.</a:t>
-            </a:r>
-          </a:p>
-          <a:p>
-            <a:r>
-              <a:t>Secondo: gli estratti conto si ricopiano a mano in VERIF!CO, il programma di contabilità.</a:t>
-            </a:r>
-          </a:p>
-          <a:p>
-            <a:r>
-              <a:t>Terzo: le foto passano su WhatsApp. Il sostenitore non ha un posto suo dove vederle.</a:t>
+              <a:t>⏱ 40 secondi</a:t>
+            </a:r>
+          </a:p>
+          <a:p>
+            <a:endParaRPr/>
+          </a:p>
+          <a:p>
+            <a:r>
+              <a:t>Prima di parlare del gestionale, due parole sull’associazione.</a:t>
+            </a:r>
+          </a:p>
+          <a:p>
+            <a:r>
+              <a:t>Effatà è nata nel 2023 per sostenere Silvia, una volontaria di Treviso che dal 2020 vive in Uganda.</a:t>
+            </a:r>
+          </a:p>
+          <a:p>
+            <a:r>
+              <a:t>Lavora in modo diretto: Silvia manda ogni giorno foto e notizie ai sostenitori su WhatsApp, e visita le famiglie.</a:t>
             </a:r>
           </a:p>
           <a:p>
@@ -1681,7 +1482,12 @@
           </a:p>
           <a:p>
             <a:r>
-              <a:t>L’idea è semplice: prima ci si registra, poi si dona. Così ogni donazione è collegata subito al bambino.</a:t>
+              <a:t>I progetti: circa 1.200 bambini a scuola; per le famiglie casette, terreni, animali, materassi e scarpe; operazioni chirurgiche; e una casa famiglia che accoglie già 38 orfani.</a:t>
+            </a:r>
+          </a:p>
+          <a:p>
+            <a:r>
+              <a:t>L’obiettivo è una relazione fra chi dona e chi riceve. Il gestionale serve a renderla tracciabile.</a:t>
             </a:r>
           </a:p>
         </p:txBody>
@@ -1693,7 +1499,7 @@
             <a:spLocks noGrp="1"/>
           </p:cNvSpPr>
           <p:nvPr>
-            <p:ph type="sldNum" idx="5" sz="quarter"/>
+            <p:ph type="sldNum" sz="quarter" idx="5"/>
           </p:nvPr>
         </p:nvSpPr>
         <p:spPr/>
@@ -1706,8 +1512,8 @@
 </p:notes>
 </file>
 
-<file path=ppt/notesSlides/notesSlide4.xml><?xml version="1.0" encoding="utf-8"?>
-<p:notes xmlns:a="http://schemas.openxmlformats.org/drawingml/2006/main" xmlns:p="http://schemas.openxmlformats.org/presentationml/2006/main" xmlns:r="http://schemas.openxmlformats.org/officeDocument/2006/relationships">
+<file path=ppt/notesSlides/notesSlide3.xml><?xml version="1.0" encoding="utf-8"?>
+<p:notes xmlns:a="http://schemas.openxmlformats.org/drawingml/2006/main" xmlns:r="http://schemas.openxmlformats.org/officeDocument/2006/relationships" xmlns:p="http://schemas.openxmlformats.org/presentationml/2006/main">
   <p:cSld>
     <p:spTree>
       <p:nvGrpSpPr>
@@ -1727,7 +1533,7 @@
         <p:nvSpPr>
           <p:cNvPr id="2" name="Slide Image Placeholder 1"/>
           <p:cNvSpPr>
-            <a:spLocks noGrp="1"/>
+            <a:spLocks noGrp="1" noRot="1" noChangeAspect="1"/>
           </p:cNvSpPr>
           <p:nvPr>
             <p:ph type="sldImg" idx="2"/>
@@ -1742,7 +1548,7 @@
             <a:spLocks noGrp="1"/>
           </p:cNvSpPr>
           <p:nvPr>
-            <p:ph type="body" idx="3" sz="quarter"/>
+            <p:ph type="body" sz="quarter" idx="3"/>
           </p:nvPr>
         </p:nvSpPr>
         <p:spPr/>
@@ -1754,25 +1560,32 @@
               <a:t>⏱ 45 secondi</a:t>
             </a:r>
           </a:p>
-          <a:p/>
-          <a:p>
-            <a:r>
-              <a:t>Il lavoro è diviso in tre parti.</a:t>
-            </a:r>
-          </a:p>
-          <a:p>
-            <a:r>
-              <a:t>La fase 1 va online ad aprile 2027: vetrina, carrello, pagamenti, rendicontazione con il bot, file per VERIF!CO.</a:t>
-            </a:r>
-          </a:p>
-          <a:p>
-            <a:r>
-              <a:t>La fase 2 arriva dopo: per esempio l’area soci e PayPal.</a:t>
-            </a:r>
-          </a:p>
-          <a:p>
-            <a:r>
-              <a:t>Fuori perimetro: chat, app sugli store, inglese.</a:t>
+          <a:p>
+            <a:endParaRPr/>
+          </a:p>
+          <a:p>
+            <a:r>
+              <a:t>Effatà segue circa 700 padrini, più di mille donatori e 1.200 bambini.</a:t>
+            </a:r>
+          </a:p>
+          <a:p>
+            <a:r>
+              <a:t>Oggi ci sono tre problemi.</a:t>
+            </a:r>
+          </a:p>
+          <a:p>
+            <a:r>
+              <a:t>Primo: molti fanno il bonifico prima di registrarsi. I dati si cercano dopo.</a:t>
+            </a:r>
+          </a:p>
+          <a:p>
+            <a:r>
+              <a:t>Secondo: gli estratti conto si ricopiano a mano in VERIF!CO, il programma di contabilità.</a:t>
+            </a:r>
+          </a:p>
+          <a:p>
+            <a:r>
+              <a:t>Terzo: le foto passano su WhatsApp. Il sostenitore non ha un posto suo dove vederle.</a:t>
             </a:r>
           </a:p>
           <a:p>
@@ -1782,7 +1595,7 @@
           </a:p>
           <a:p>
             <a:r>
-              <a:t>Una scelta importante: il gestionale non sostituisce VERIF!CO. La contabilità resta lì. Noi prepariamo solo i dati, senza ricopiarli.</a:t>
+              <a:t>L’idea è semplice: prima ci si registra, poi si dona. Così ogni donazione è collegata subito al bambino.</a:t>
             </a:r>
           </a:p>
         </p:txBody>
@@ -1794,7 +1607,7 @@
             <a:spLocks noGrp="1"/>
           </p:cNvSpPr>
           <p:nvPr>
-            <p:ph type="sldNum" idx="5" sz="quarter"/>
+            <p:ph type="sldNum" sz="quarter" idx="5"/>
           </p:nvPr>
         </p:nvSpPr>
         <p:spPr/>
@@ -1807,8 +1620,8 @@
 </p:notes>
 </file>
 
-<file path=ppt/notesSlides/notesSlide5.xml><?xml version="1.0" encoding="utf-8"?>
-<p:notes xmlns:a="http://schemas.openxmlformats.org/drawingml/2006/main" xmlns:p="http://schemas.openxmlformats.org/presentationml/2006/main" xmlns:r="http://schemas.openxmlformats.org/officeDocument/2006/relationships">
+<file path=ppt/notesSlides/notesSlide4.xml><?xml version="1.0" encoding="utf-8"?>
+<p:notes xmlns:a="http://schemas.openxmlformats.org/drawingml/2006/main" xmlns:r="http://schemas.openxmlformats.org/officeDocument/2006/relationships" xmlns:p="http://schemas.openxmlformats.org/presentationml/2006/main">
   <p:cSld>
     <p:spTree>
       <p:nvGrpSpPr>
@@ -1828,7 +1641,7 @@
         <p:nvSpPr>
           <p:cNvPr id="2" name="Slide Image Placeholder 1"/>
           <p:cNvSpPr>
-            <a:spLocks noGrp="1"/>
+            <a:spLocks noGrp="1" noRot="1" noChangeAspect="1"/>
           </p:cNvSpPr>
           <p:nvPr>
             <p:ph type="sldImg" idx="2"/>
@@ -1843,7 +1656,7 @@
             <a:spLocks noGrp="1"/>
           </p:cNvSpPr>
           <p:nvPr>
-            <p:ph type="body" idx="3" sz="quarter"/>
+            <p:ph type="body" sz="quarter" idx="3"/>
           </p:nvPr>
         </p:nvSpPr>
         <p:spPr/>
@@ -1855,20 +1668,27 @@
               <a:t>⏱ 45 secondi</a:t>
             </a:r>
           </a:p>
-          <a:p/>
-          <a:p>
-            <a:r>
-              <a:t>Gli stakeholder sono le persone che hanno un interesse nel progetto. Sono dieci.</a:t>
-            </a:r>
-          </a:p>
-          <a:p>
-            <a:r>
-              <a:t>In verde chi userà il gestionale: amministratori, volontari, sostenitori e soci.</a:t>
-            </a:r>
-          </a:p>
-          <a:p>
-            <a:r>
-              <a:t>In arancione chi è coinvolto senza usarlo: Silvia, la referente in Uganda; i bambini e le famiglie; il commercialista; il docente; chi manterrà il sistema.</a:t>
+          <a:p>
+            <a:endParaRPr/>
+          </a:p>
+          <a:p>
+            <a:r>
+              <a:t>Il lavoro è diviso in tre parti.</a:t>
+            </a:r>
+          </a:p>
+          <a:p>
+            <a:r>
+              <a:t>La fase 1 va online ad aprile 2027: vetrina, carrello, pagamenti, rendicontazione con il bot, file per VERIF!CO.</a:t>
+            </a:r>
+          </a:p>
+          <a:p>
+            <a:r>
+              <a:t>La fase 2 arriva dopo: per esempio l’area soci e PayPal.</a:t>
+            </a:r>
+          </a:p>
+          <a:p>
+            <a:r>
+              <a:t>Fuori perimetro: chat, app sugli store, inglese.</a:t>
             </a:r>
           </a:p>
           <a:p>
@@ -1878,7 +1698,7 @@
           </a:p>
           <a:p>
             <a:r>
-              <a:t>VERIF!CO, la banca e gli altri sono fornitori. Li tratto come dipendenze, nel capitolo 7.</a:t>
+              <a:t>Una scelta importante: il gestionale non sostituisce VERIF!CO. La contabilità resta lì. Noi prepariamo solo i dati, senza ricopiarli.</a:t>
             </a:r>
           </a:p>
         </p:txBody>
@@ -1890,7 +1710,7 @@
             <a:spLocks noGrp="1"/>
           </p:cNvSpPr>
           <p:nvPr>
-            <p:ph type="sldNum" idx="5" sz="quarter"/>
+            <p:ph type="sldNum" sz="quarter" idx="5"/>
           </p:nvPr>
         </p:nvSpPr>
         <p:spPr/>
@@ -1903,8 +1723,8 @@
 </p:notes>
 </file>
 
-<file path=ppt/notesSlides/notesSlide6.xml><?xml version="1.0" encoding="utf-8"?>
-<p:notes xmlns:a="http://schemas.openxmlformats.org/drawingml/2006/main" xmlns:p="http://schemas.openxmlformats.org/presentationml/2006/main" xmlns:r="http://schemas.openxmlformats.org/officeDocument/2006/relationships">
+<file path=ppt/notesSlides/notesSlide5.xml><?xml version="1.0" encoding="utf-8"?>
+<p:notes xmlns:a="http://schemas.openxmlformats.org/drawingml/2006/main" xmlns:r="http://schemas.openxmlformats.org/officeDocument/2006/relationships" xmlns:p="http://schemas.openxmlformats.org/presentationml/2006/main">
   <p:cSld>
     <p:spTree>
       <p:nvGrpSpPr>
@@ -1924,7 +1744,7 @@
         <p:nvSpPr>
           <p:cNvPr id="2" name="Slide Image Placeholder 1"/>
           <p:cNvSpPr>
-            <a:spLocks noGrp="1"/>
+            <a:spLocks noGrp="1" noRot="1" noChangeAspect="1"/>
           </p:cNvSpPr>
           <p:nvPr>
             <p:ph type="sldImg" idx="2"/>
@@ -1939,7 +1759,7 @@
             <a:spLocks noGrp="1"/>
           </p:cNvSpPr>
           <p:nvPr>
-            <p:ph type="body" idx="3" sz="quarter"/>
+            <p:ph type="body" sz="quarter" idx="3"/>
           </p:nvPr>
         </p:nvSpPr>
         <p:spPr/>
@@ -1951,30 +1771,22 @@
               <a:t>⏱ 45 secondi</a:t>
             </a:r>
           </a:p>
-          <a:p/>
-          <a:p>
-            <a:r>
-              <a:t>Gli utenti sono di quattro tipi.</a:t>
-            </a:r>
-          </a:p>
-          <a:p>
-            <a:r>
-              <a:t>L’amministratore lavora dal computer.</a:t>
-            </a:r>
-          </a:p>
-          <a:p>
-            <a:r>
-              <a:t>I volontari lavorano la sera, soprattutto dal bot Telegram che già usano.</a:t>
-            </a:r>
-          </a:p>
-          <a:p>
-            <a:r>
-              <a:t>I sostenitori usano il telefono, una o due volte al mese. Molti non sono giovani: per questo le pagine devono essere molto leggibili.</a:t>
-            </a:r>
-          </a:p>
-          <a:p>
-            <a:r>
-              <a:t>I soci arrivano nella fase 2.</a:t>
+          <a:p>
+            <a:endParaRPr/>
+          </a:p>
+          <a:p>
+            <a:r>
+              <a:t>Gli stakeholder sono le persone che hanno un interesse nel progetto. Sono dieci.</a:t>
+            </a:r>
+          </a:p>
+          <a:p>
+            <a:r>
+              <a:t>In verde chi userà il gestionale: amministratori, volontari, sostenitori e soci.</a:t>
+            </a:r>
+          </a:p>
+          <a:p>
+            <a:r>
+              <a:t>In arancione chi è coinvolto senza usarlo: Silvia, la referente in Uganda; i bambini e le famiglie; il commercialista; il docente; chi manterrà il sistema.</a:t>
             </a:r>
           </a:p>
           <a:p>
@@ -1984,7 +1796,7 @@
           </a:p>
           <a:p>
             <a:r>
-              <a:t>A destra il cambiamento: oggi tutto si ricopia a mano. Domani il sostenitore si registra, paga e vede le foto nella sua area.</a:t>
+              <a:t>VERIF!CO, la banca e gli altri sono fornitori. Li tratto come dipendenze, nel capitolo 7.</a:t>
             </a:r>
           </a:p>
         </p:txBody>
@@ -1996,7 +1808,7 @@
             <a:spLocks noGrp="1"/>
           </p:cNvSpPr>
           <p:nvPr>
-            <p:ph type="sldNum" idx="5" sz="quarter"/>
+            <p:ph type="sldNum" sz="quarter" idx="5"/>
           </p:nvPr>
         </p:nvSpPr>
         <p:spPr/>
@@ -2009,8 +1821,8 @@
 </p:notes>
 </file>
 
-<file path=ppt/notesSlides/notesSlide7.xml><?xml version="1.0" encoding="utf-8"?>
-<p:notes xmlns:a="http://schemas.openxmlformats.org/drawingml/2006/main" xmlns:p="http://schemas.openxmlformats.org/presentationml/2006/main" xmlns:r="http://schemas.openxmlformats.org/officeDocument/2006/relationships">
+<file path=ppt/notesSlides/notesSlide6.xml><?xml version="1.0" encoding="utf-8"?>
+<p:notes xmlns:a="http://schemas.openxmlformats.org/drawingml/2006/main" xmlns:r="http://schemas.openxmlformats.org/officeDocument/2006/relationships" xmlns:p="http://schemas.openxmlformats.org/presentationml/2006/main">
   <p:cSld>
     <p:spTree>
       <p:nvGrpSpPr>
@@ -2030,7 +1842,7 @@
         <p:nvSpPr>
           <p:cNvPr id="2" name="Slide Image Placeholder 1"/>
           <p:cNvSpPr>
-            <a:spLocks noGrp="1"/>
+            <a:spLocks noGrp="1" noRot="1" noChangeAspect="1"/>
           </p:cNvSpPr>
           <p:nvPr>
             <p:ph type="sldImg" idx="2"/>
@@ -2045,7 +1857,7 @@
             <a:spLocks noGrp="1"/>
           </p:cNvSpPr>
           <p:nvPr>
-            <p:ph type="body" idx="3" sz="quarter"/>
+            <p:ph type="body" sz="quarter" idx="3"/>
           </p:nvPr>
         </p:nvSpPr>
         <p:spPr/>
@@ -2057,20 +1869,32 @@
               <a:t>⏱ 45 secondi</a:t>
             </a:r>
           </a:p>
-          <a:p/>
-          <a:p>
-            <a:r>
-              <a:t>Il cuore è un carrello solidale.</a:t>
-            </a:r>
-          </a:p>
-          <a:p>
-            <a:r>
-              <a:t>Come un negozio online, ma al posto dei prodotti ci sono bisogni veri: la scuola di una bambina, una carrozzina, una capretta.</a:t>
-            </a:r>
-          </a:p>
-          <a:p>
-            <a:r>
-              <a:t>Il sostenitore sceglie e paga con carta, Satispay o bonifico. Riceve subito il ringraziamento.</a:t>
+          <a:p>
+            <a:endParaRPr/>
+          </a:p>
+          <a:p>
+            <a:r>
+              <a:t>Gli utenti sono di quattro tipi.</a:t>
+            </a:r>
+          </a:p>
+          <a:p>
+            <a:r>
+              <a:t>L’amministratore lavora dal computer.</a:t>
+            </a:r>
+          </a:p>
+          <a:p>
+            <a:r>
+              <a:t>I volontari lavorano la sera, soprattutto dal bot Telegram che già usano.</a:t>
+            </a:r>
+          </a:p>
+          <a:p>
+            <a:r>
+              <a:t>I sostenitori usano il telefono, una o due volte al mese. Molti non sono giovani: per questo le pagine devono essere molto leggibili.</a:t>
+            </a:r>
+          </a:p>
+          <a:p>
+            <a:r>
+              <a:t>I soci arrivano nella fase 2.</a:t>
             </a:r>
           </a:p>
           <a:p>
@@ -2080,7 +1904,7 @@
           </a:p>
           <a:p>
             <a:r>
-              <a:t>Poi, nella sua area, vede le foto della consegna. Solo di quello che ha sostenuto lui.</a:t>
+              <a:t>A destra il cambiamento: oggi tutto si ricopia a mano. Domani il sostenitore si registra, paga e vede le foto nella sua area.</a:t>
             </a:r>
           </a:p>
         </p:txBody>
@@ -2092,7 +1916,7 @@
             <a:spLocks noGrp="1"/>
           </p:cNvSpPr>
           <p:nvPr>
-            <p:ph type="sldNum" idx="5" sz="quarter"/>
+            <p:ph type="sldNum" sz="quarter" idx="5"/>
           </p:nvPr>
         </p:nvSpPr>
         <p:spPr/>
@@ -2105,8 +1929,8 @@
 </p:notes>
 </file>
 
-<file path=ppt/notesSlides/notesSlide8.xml><?xml version="1.0" encoding="utf-8"?>
-<p:notes xmlns:a="http://schemas.openxmlformats.org/drawingml/2006/main" xmlns:p="http://schemas.openxmlformats.org/presentationml/2006/main" xmlns:r="http://schemas.openxmlformats.org/officeDocument/2006/relationships">
+<file path=ppt/notesSlides/notesSlide7.xml><?xml version="1.0" encoding="utf-8"?>
+<p:notes xmlns:a="http://schemas.openxmlformats.org/drawingml/2006/main" xmlns:r="http://schemas.openxmlformats.org/officeDocument/2006/relationships" xmlns:p="http://schemas.openxmlformats.org/presentationml/2006/main">
   <p:cSld>
     <p:spTree>
       <p:nvGrpSpPr>
@@ -2126,7 +1950,7 @@
         <p:nvSpPr>
           <p:cNvPr id="2" name="Slide Image Placeholder 1"/>
           <p:cNvSpPr>
-            <a:spLocks noGrp="1"/>
+            <a:spLocks noGrp="1" noRot="1" noChangeAspect="1"/>
           </p:cNvSpPr>
           <p:nvPr>
             <p:ph type="sldImg" idx="2"/>
@@ -2141,7 +1965,7 @@
             <a:spLocks noGrp="1"/>
           </p:cNvSpPr>
           <p:nvPr>
-            <p:ph type="body" idx="3" sz="quarter"/>
+            <p:ph type="body" sz="quarter" idx="3"/>
           </p:nvPr>
         </p:nvSpPr>
         <p:spPr/>
@@ -2153,35 +1977,22 @@
               <a:t>⏱ 45 secondi</a:t>
             </a:r>
           </a:p>
-          <a:p/>
-          <a:p>
-            <a:r>
-              <a:t>Questo è uno dei nove user flow: una richiesta di aiuto nuova.</a:t>
-            </a:r>
-          </a:p>
-          <a:p>
-            <a:r>
-              <a:t>Silvia manda le foto su WhatsApp, come sempre.</a:t>
-            </a:r>
-          </a:p>
-          <a:p>
-            <a:r>
-              <a:t>Il volontario le mette nel bot e sceglie “Richiesta di aiuto”.</a:t>
-            </a:r>
-          </a:p>
-          <a:p>
-            <a:r>
-              <a:t>Il bot trova il bambino giusto. Il volontario conferma.</a:t>
-            </a:r>
-          </a:p>
-          <a:p>
-            <a:r>
-              <a:t>Il bot pubblica sui social e manda tutto al gestionale.</a:t>
-            </a:r>
-          </a:p>
-          <a:p>
-            <a:r>
-              <a:t>L’amministratore approva. La richiesta va in vetrina.</a:t>
+          <a:p>
+            <a:endParaRPr/>
+          </a:p>
+          <a:p>
+            <a:r>
+              <a:t>Il cuore è un carrello solidale.</a:t>
+            </a:r>
+          </a:p>
+          <a:p>
+            <a:r>
+              <a:t>Come un negozio online, ma al posto dei prodotti ci sono bisogni veri: la scuola di una bambina, una carrozzina, una capretta.</a:t>
+            </a:r>
+          </a:p>
+          <a:p>
+            <a:r>
+              <a:t>Il sostenitore sceglie e paga con carta, Satispay o bonifico. Riceve subito il ringraziamento.</a:t>
             </a:r>
           </a:p>
           <a:p>
@@ -2191,7 +2002,7 @@
           </a:p>
           <a:p>
             <a:r>
-              <a:t>Per le foto di un aiuto già pagato, il volontario sceglie invece “Aiuto consegnato”.</a:t>
+              <a:t>Poi, nella sua area, vede le foto della consegna. Solo di quello che ha sostenuto lui.</a:t>
             </a:r>
           </a:p>
         </p:txBody>
@@ -2203,7 +2014,7 @@
             <a:spLocks noGrp="1"/>
           </p:cNvSpPr>
           <p:nvPr>
-            <p:ph type="sldNum" idx="5" sz="quarter"/>
+            <p:ph type="sldNum" sz="quarter" idx="5"/>
           </p:nvPr>
         </p:nvSpPr>
         <p:spPr/>
@@ -2216,8 +2027,8 @@
 </p:notes>
 </file>
 
-<file path=ppt/notesSlides/notesSlide9.xml><?xml version="1.0" encoding="utf-8"?>
-<p:notes xmlns:a="http://schemas.openxmlformats.org/drawingml/2006/main" xmlns:p="http://schemas.openxmlformats.org/presentationml/2006/main" xmlns:r="http://schemas.openxmlformats.org/officeDocument/2006/relationships">
+<file path=ppt/notesSlides/notesSlide8.xml><?xml version="1.0" encoding="utf-8"?>
+<p:notes xmlns:a="http://schemas.openxmlformats.org/drawingml/2006/main" xmlns:r="http://schemas.openxmlformats.org/officeDocument/2006/relationships" xmlns:p="http://schemas.openxmlformats.org/presentationml/2006/main">
   <p:cSld>
     <p:spTree>
       <p:nvGrpSpPr>
@@ -2237,7 +2048,7 @@
         <p:nvSpPr>
           <p:cNvPr id="2" name="Slide Image Placeholder 1"/>
           <p:cNvSpPr>
-            <a:spLocks noGrp="1"/>
+            <a:spLocks noGrp="1" noRot="1" noChangeAspect="1"/>
           </p:cNvSpPr>
           <p:nvPr>
             <p:ph type="sldImg" idx="2"/>
@@ -2252,7 +2063,7 @@
             <a:spLocks noGrp="1"/>
           </p:cNvSpPr>
           <p:nvPr>
-            <p:ph type="body" idx="3" sz="quarter"/>
+            <p:ph type="body" sz="quarter" idx="3"/>
           </p:nvPr>
         </p:nvSpPr>
         <p:spPr/>
@@ -2261,10 +2072,125 @@
           <a:lstStyle/>
           <a:p>
             <a:r>
+              <a:t>⏱ 45 secondi</a:t>
+            </a:r>
+          </a:p>
+          <a:p>
+            <a:endParaRPr/>
+          </a:p>
+          <a:p>
+            <a:r>
+              <a:t>Questo è uno dei nove user flow: una richiesta di aiuto nuova.</a:t>
+            </a:r>
+          </a:p>
+          <a:p>
+            <a:r>
+              <a:t>Silvia manda le foto su WhatsApp, come sempre.</a:t>
+            </a:r>
+          </a:p>
+          <a:p>
+            <a:r>
+              <a:t>Il volontario le mette nel bot e sceglie “Richiesta di aiuto”.</a:t>
+            </a:r>
+          </a:p>
+          <a:p>
+            <a:r>
+              <a:t>Il bot trova il bambino giusto. Il volontario conferma.</a:t>
+            </a:r>
+          </a:p>
+          <a:p>
+            <a:r>
+              <a:t>Il bot pubblica sui social e manda tutto al gestionale.</a:t>
+            </a:r>
+          </a:p>
+          <a:p>
+            <a:r>
+              <a:t>L’amministratore approva. La richiesta va in vetrina.</a:t>
+            </a:r>
+          </a:p>
+          <a:p>
+            <a:r>
+              <a:t>— pausa —</a:t>
+            </a:r>
+          </a:p>
+          <a:p>
+            <a:r>
+              <a:t>Per le foto di un aiuto già pagato, il volontario sceglie invece “Aiuto consegnato”.</a:t>
+            </a:r>
+          </a:p>
+        </p:txBody>
+      </p:sp>
+      <p:sp>
+        <p:nvSpPr>
+          <p:cNvPr id="4" name="Slide Number Placeholder 3"/>
+          <p:cNvSpPr>
+            <a:spLocks noGrp="1"/>
+          </p:cNvSpPr>
+          <p:nvPr>
+            <p:ph type="sldNum" sz="quarter" idx="5"/>
+          </p:nvPr>
+        </p:nvSpPr>
+        <p:spPr/>
+      </p:sp>
+    </p:spTree>
+  </p:cSld>
+  <p:clrMapOvr>
+    <a:masterClrMapping/>
+  </p:clrMapOvr>
+</p:notes>
+</file>
+
+<file path=ppt/notesSlides/notesSlide9.xml><?xml version="1.0" encoding="utf-8"?>
+<p:notes xmlns:a="http://schemas.openxmlformats.org/drawingml/2006/main" xmlns:r="http://schemas.openxmlformats.org/officeDocument/2006/relationships" xmlns:p="http://schemas.openxmlformats.org/presentationml/2006/main">
+  <p:cSld>
+    <p:spTree>
+      <p:nvGrpSpPr>
+        <p:cNvPr id="1" name=""/>
+        <p:cNvGrpSpPr/>
+        <p:nvPr/>
+      </p:nvGrpSpPr>
+      <p:grpSpPr>
+        <a:xfrm>
+          <a:off x="0" y="0"/>
+          <a:ext cx="0" cy="0"/>
+          <a:chOff x="0" y="0"/>
+          <a:chExt cx="0" cy="0"/>
+        </a:xfrm>
+      </p:grpSpPr>
+      <p:sp>
+        <p:nvSpPr>
+          <p:cNvPr id="2" name="Slide Image Placeholder 1"/>
+          <p:cNvSpPr>
+            <a:spLocks noGrp="1" noRot="1" noChangeAspect="1"/>
+          </p:cNvSpPr>
+          <p:nvPr>
+            <p:ph type="sldImg" idx="2"/>
+          </p:nvPr>
+        </p:nvSpPr>
+        <p:spPr/>
+      </p:sp>
+      <p:sp>
+        <p:nvSpPr>
+          <p:cNvPr id="3" name="Notes Placeholder 2"/>
+          <p:cNvSpPr>
+            <a:spLocks noGrp="1"/>
+          </p:cNvSpPr>
+          <p:nvPr>
+            <p:ph type="body" sz="quarter" idx="3"/>
+          </p:nvPr>
+        </p:nvSpPr>
+        <p:spPr/>
+        <p:txBody>
+          <a:bodyPr/>
+          <a:lstStyle/>
+          <a:p>
+            <a:r>
               <a:t>⏱ 75 secondi</a:t>
             </a:r>
           </a:p>
-          <a:p/>
+          <a:p>
+            <a:endParaRPr/>
+          </a:p>
           <a:p>
             <a:r>
               <a:t>Il capitolo 5 ha 25 user story. Sono scritte così: “Come… voglio… così da…”.</a:t>
@@ -2334,7 +2260,7 @@
             <a:spLocks noGrp="1"/>
           </p:cNvSpPr>
           <p:nvPr>
-            <p:ph type="sldNum" idx="5" sz="quarter"/>
+            <p:ph type="sldNum" sz="quarter" idx="5"/>
           </p:nvPr>
         </p:nvSpPr>
         <p:spPr/>
@@ -2385,10 +2311,9 @@
           <a:lstStyle/>
           <a:p>
             <a:r>
-              <a:rPr lang="en-US" smtClean="0"/>
+              <a:rPr lang="en-US"/>
               <a:t>Click to edit Master title style</a:t>
             </a:r>
-            <a:endParaRPr lang="en-US"/>
           </a:p>
         </p:txBody>
       </p:sp>
@@ -2504,10 +2429,9 @@
           </a:lstStyle>
           <a:p>
             <a:r>
-              <a:rPr lang="en-US" smtClean="0"/>
+              <a:rPr lang="en-US"/>
               <a:t>Click to edit Master subtitle style</a:t>
             </a:r>
-            <a:endParaRPr lang="en-US"/>
           </a:p>
         </p:txBody>
       </p:sp>
@@ -2528,7 +2452,7 @@
           <a:p>
             <a:fld id="{5BCAD085-E8A6-8845-BD4E-CB4CCA059FC4}" type="datetimeFigureOut">
               <a:rPr lang="en-US" smtClean="0"/>
-              <a:t>1/27/13</a:t>
+              <a:t>10/28/2026</a:t>
             </a:fld>
             <a:endParaRPr lang="en-US"/>
           </a:p>
@@ -2570,7 +2494,7 @@
           <a:p>
             <a:fld id="{C1FF6DA9-008F-8B48-92A6-B652298478BF}" type="slidenum">
               <a:rPr lang="en-US" smtClean="0"/>
-              <a:t>‹#›</a:t>
+              <a:t>‹N›</a:t>
             </a:fld>
             <a:endParaRPr lang="en-US"/>
           </a:p>
@@ -2622,10 +2546,9 @@
           <a:lstStyle/>
           <a:p>
             <a:r>
-              <a:rPr lang="en-US" smtClean="0"/>
+              <a:rPr lang="en-US"/>
               <a:t>Click to edit Master title style</a:t>
             </a:r>
-            <a:endParaRPr lang="en-US"/>
           </a:p>
         </p:txBody>
       </p:sp>
@@ -2646,38 +2569,37 @@
           <a:p>
             <a:pPr lvl="0"/>
             <a:r>
-              <a:rPr lang="en-US" smtClean="0"/>
+              <a:rPr lang="en-US"/>
               <a:t>Click to edit Master text styles</a:t>
             </a:r>
           </a:p>
           <a:p>
             <a:pPr lvl="1"/>
             <a:r>
-              <a:rPr lang="en-US" smtClean="0"/>
+              <a:rPr lang="en-US"/>
               <a:t>Second level</a:t>
             </a:r>
           </a:p>
           <a:p>
             <a:pPr lvl="2"/>
             <a:r>
-              <a:rPr lang="en-US" smtClean="0"/>
+              <a:rPr lang="en-US"/>
               <a:t>Third level</a:t>
             </a:r>
           </a:p>
           <a:p>
             <a:pPr lvl="3"/>
             <a:r>
-              <a:rPr lang="en-US" smtClean="0"/>
+              <a:rPr lang="en-US"/>
               <a:t>Fourth level</a:t>
             </a:r>
           </a:p>
           <a:p>
             <a:pPr lvl="4"/>
             <a:r>
-              <a:rPr lang="en-US" smtClean="0"/>
+              <a:rPr lang="en-US"/>
               <a:t>Fifth level</a:t>
             </a:r>
-            <a:endParaRPr lang="en-US"/>
           </a:p>
         </p:txBody>
       </p:sp>
@@ -2698,7 +2620,7 @@
           <a:p>
             <a:fld id="{5BCAD085-E8A6-8845-BD4E-CB4CCA059FC4}" type="datetimeFigureOut">
               <a:rPr lang="en-US" smtClean="0"/>
-              <a:t>1/27/13</a:t>
+              <a:t>10/28/2026</a:t>
             </a:fld>
             <a:endParaRPr lang="en-US"/>
           </a:p>
@@ -2740,7 +2662,7 @@
           <a:p>
             <a:fld id="{C1FF6DA9-008F-8B48-92A6-B652298478BF}" type="slidenum">
               <a:rPr lang="en-US" smtClean="0"/>
-              <a:t>‹#›</a:t>
+              <a:t>‹N›</a:t>
             </a:fld>
             <a:endParaRPr lang="en-US"/>
           </a:p>
@@ -2797,10 +2719,9 @@
           <a:lstStyle/>
           <a:p>
             <a:r>
-              <a:rPr lang="en-US" smtClean="0"/>
+              <a:rPr lang="en-US"/>
               <a:t>Click to edit Master title style</a:t>
             </a:r>
-            <a:endParaRPr lang="en-US"/>
           </a:p>
         </p:txBody>
       </p:sp>
@@ -2826,38 +2747,37 @@
           <a:p>
             <a:pPr lvl="0"/>
             <a:r>
-              <a:rPr lang="en-US" smtClean="0"/>
+              <a:rPr lang="en-US"/>
               <a:t>Click to edit Master text styles</a:t>
             </a:r>
           </a:p>
           <a:p>
             <a:pPr lvl="1"/>
             <a:r>
-              <a:rPr lang="en-US" smtClean="0"/>
+              <a:rPr lang="en-US"/>
               <a:t>Second level</a:t>
             </a:r>
           </a:p>
           <a:p>
             <a:pPr lvl="2"/>
             <a:r>
-              <a:rPr lang="en-US" smtClean="0"/>
+              <a:rPr lang="en-US"/>
               <a:t>Third level</a:t>
             </a:r>
           </a:p>
           <a:p>
             <a:pPr lvl="3"/>
             <a:r>
-              <a:rPr lang="en-US" smtClean="0"/>
+              <a:rPr lang="en-US"/>
               <a:t>Fourth level</a:t>
             </a:r>
           </a:p>
           <a:p>
             <a:pPr lvl="4"/>
             <a:r>
-              <a:rPr lang="en-US" smtClean="0"/>
+              <a:rPr lang="en-US"/>
               <a:t>Fifth level</a:t>
             </a:r>
-            <a:endParaRPr lang="en-US"/>
           </a:p>
         </p:txBody>
       </p:sp>
@@ -2878,7 +2798,7 @@
           <a:p>
             <a:fld id="{5BCAD085-E8A6-8845-BD4E-CB4CCA059FC4}" type="datetimeFigureOut">
               <a:rPr lang="en-US" smtClean="0"/>
-              <a:t>1/27/13</a:t>
+              <a:t>10/28/2026</a:t>
             </a:fld>
             <a:endParaRPr lang="en-US"/>
           </a:p>
@@ -2920,7 +2840,7 @@
           <a:p>
             <a:fld id="{C1FF6DA9-008F-8B48-92A6-B652298478BF}" type="slidenum">
               <a:rPr lang="en-US" smtClean="0"/>
-              <a:t>‹#›</a:t>
+              <a:t>‹N›</a:t>
             </a:fld>
             <a:endParaRPr lang="en-US"/>
           </a:p>
@@ -2972,10 +2892,9 @@
           <a:lstStyle/>
           <a:p>
             <a:r>
-              <a:rPr lang="en-US" smtClean="0"/>
+              <a:rPr lang="en-US"/>
               <a:t>Click to edit Master title style</a:t>
             </a:r>
-            <a:endParaRPr lang="en-US"/>
           </a:p>
         </p:txBody>
       </p:sp>
@@ -2996,38 +2915,37 @@
           <a:p>
             <a:pPr lvl="0"/>
             <a:r>
-              <a:rPr lang="en-US" smtClean="0"/>
+              <a:rPr lang="en-US"/>
               <a:t>Click to edit Master text styles</a:t>
             </a:r>
           </a:p>
           <a:p>
             <a:pPr lvl="1"/>
             <a:r>
-              <a:rPr lang="en-US" smtClean="0"/>
+              <a:rPr lang="en-US"/>
               <a:t>Second level</a:t>
             </a:r>
           </a:p>
           <a:p>
             <a:pPr lvl="2"/>
             <a:r>
-              <a:rPr lang="en-US" smtClean="0"/>
+              <a:rPr lang="en-US"/>
               <a:t>Third level</a:t>
             </a:r>
           </a:p>
           <a:p>
             <a:pPr lvl="3"/>
             <a:r>
-              <a:rPr lang="en-US" smtClean="0"/>
+              <a:rPr lang="en-US"/>
               <a:t>Fourth level</a:t>
             </a:r>
           </a:p>
           <a:p>
             <a:pPr lvl="4"/>
             <a:r>
-              <a:rPr lang="en-US" smtClean="0"/>
+              <a:rPr lang="en-US"/>
               <a:t>Fifth level</a:t>
             </a:r>
-            <a:endParaRPr lang="en-US"/>
           </a:p>
         </p:txBody>
       </p:sp>
@@ -3048,7 +2966,7 @@
           <a:p>
             <a:fld id="{5BCAD085-E8A6-8845-BD4E-CB4CCA059FC4}" type="datetimeFigureOut">
               <a:rPr lang="en-US" smtClean="0"/>
-              <a:t>1/27/13</a:t>
+              <a:t>10/28/2026</a:t>
             </a:fld>
             <a:endParaRPr lang="en-US"/>
           </a:p>
@@ -3090,7 +3008,7 @@
           <a:p>
             <a:fld id="{C1FF6DA9-008F-8B48-92A6-B652298478BF}" type="slidenum">
               <a:rPr lang="en-US" smtClean="0"/>
-              <a:t>‹#›</a:t>
+              <a:t>‹N›</a:t>
             </a:fld>
             <a:endParaRPr lang="en-US"/>
           </a:p>
@@ -3151,10 +3069,9 @@
           </a:lstStyle>
           <a:p>
             <a:r>
-              <a:rPr lang="en-US" smtClean="0"/>
+              <a:rPr lang="en-US"/>
               <a:t>Click to edit Master title style</a:t>
             </a:r>
-            <a:endParaRPr lang="en-US"/>
           </a:p>
         </p:txBody>
       </p:sp>
@@ -3271,7 +3188,7 @@
           <a:p>
             <a:pPr lvl="0"/>
             <a:r>
-              <a:rPr lang="en-US" smtClean="0"/>
+              <a:rPr lang="en-US"/>
               <a:t>Click to edit Master text styles</a:t>
             </a:r>
           </a:p>
@@ -3294,7 +3211,7 @@
           <a:p>
             <a:fld id="{5BCAD085-E8A6-8845-BD4E-CB4CCA059FC4}" type="datetimeFigureOut">
               <a:rPr lang="en-US" smtClean="0"/>
-              <a:t>1/27/13</a:t>
+              <a:t>10/28/2026</a:t>
             </a:fld>
             <a:endParaRPr lang="en-US"/>
           </a:p>
@@ -3336,7 +3253,7 @@
           <a:p>
             <a:fld id="{C1FF6DA9-008F-8B48-92A6-B652298478BF}" type="slidenum">
               <a:rPr lang="en-US" smtClean="0"/>
-              <a:t>‹#›</a:t>
+              <a:t>‹N›</a:t>
             </a:fld>
             <a:endParaRPr lang="en-US"/>
           </a:p>
@@ -3388,10 +3305,9 @@
           <a:lstStyle/>
           <a:p>
             <a:r>
-              <a:rPr lang="en-US" smtClean="0"/>
+              <a:rPr lang="en-US"/>
               <a:t>Click to edit Master title style</a:t>
             </a:r>
-            <a:endParaRPr lang="en-US"/>
           </a:p>
         </p:txBody>
       </p:sp>
@@ -3445,38 +3361,37 @@
           <a:p>
             <a:pPr lvl="0"/>
             <a:r>
-              <a:rPr lang="en-US" smtClean="0"/>
+              <a:rPr lang="en-US"/>
               <a:t>Click to edit Master text styles</a:t>
             </a:r>
           </a:p>
           <a:p>
             <a:pPr lvl="1"/>
             <a:r>
-              <a:rPr lang="en-US" smtClean="0"/>
+              <a:rPr lang="en-US"/>
               <a:t>Second level</a:t>
             </a:r>
           </a:p>
           <a:p>
             <a:pPr lvl="2"/>
             <a:r>
-              <a:rPr lang="en-US" smtClean="0"/>
+              <a:rPr lang="en-US"/>
               <a:t>Third level</a:t>
             </a:r>
           </a:p>
           <a:p>
             <a:pPr lvl="3"/>
             <a:r>
-              <a:rPr lang="en-US" smtClean="0"/>
+              <a:rPr lang="en-US"/>
               <a:t>Fourth level</a:t>
             </a:r>
           </a:p>
           <a:p>
             <a:pPr lvl="4"/>
             <a:r>
-              <a:rPr lang="en-US" smtClean="0"/>
+              <a:rPr lang="en-US"/>
               <a:t>Fifth level</a:t>
             </a:r>
-            <a:endParaRPr lang="en-US"/>
           </a:p>
         </p:txBody>
       </p:sp>
@@ -3530,38 +3445,37 @@
           <a:p>
             <a:pPr lvl="0"/>
             <a:r>
-              <a:rPr lang="en-US" smtClean="0"/>
+              <a:rPr lang="en-US"/>
               <a:t>Click to edit Master text styles</a:t>
             </a:r>
           </a:p>
           <a:p>
             <a:pPr lvl="1"/>
             <a:r>
-              <a:rPr lang="en-US" smtClean="0"/>
+              <a:rPr lang="en-US"/>
               <a:t>Second level</a:t>
             </a:r>
           </a:p>
           <a:p>
             <a:pPr lvl="2"/>
             <a:r>
-              <a:rPr lang="en-US" smtClean="0"/>
+              <a:rPr lang="en-US"/>
               <a:t>Third level</a:t>
             </a:r>
           </a:p>
           <a:p>
             <a:pPr lvl="3"/>
             <a:r>
-              <a:rPr lang="en-US" smtClean="0"/>
+              <a:rPr lang="en-US"/>
               <a:t>Fourth level</a:t>
             </a:r>
           </a:p>
           <a:p>
             <a:pPr lvl="4"/>
             <a:r>
-              <a:rPr lang="en-US" smtClean="0"/>
+              <a:rPr lang="en-US"/>
               <a:t>Fifth level</a:t>
             </a:r>
-            <a:endParaRPr lang="en-US"/>
           </a:p>
         </p:txBody>
       </p:sp>
@@ -3582,7 +3496,7 @@
           <a:p>
             <a:fld id="{5BCAD085-E8A6-8845-BD4E-CB4CCA059FC4}" type="datetimeFigureOut">
               <a:rPr lang="en-US" smtClean="0"/>
-              <a:t>1/27/13</a:t>
+              <a:t>10/28/2026</a:t>
             </a:fld>
             <a:endParaRPr lang="en-US"/>
           </a:p>
@@ -3624,7 +3538,7 @@
           <a:p>
             <a:fld id="{C1FF6DA9-008F-8B48-92A6-B652298478BF}" type="slidenum">
               <a:rPr lang="en-US" smtClean="0"/>
-              <a:t>‹#›</a:t>
+              <a:t>‹N›</a:t>
             </a:fld>
             <a:endParaRPr lang="en-US"/>
           </a:p>
@@ -3680,10 +3594,9 @@
           </a:lstStyle>
           <a:p>
             <a:r>
-              <a:rPr lang="en-US" smtClean="0"/>
+              <a:rPr lang="en-US"/>
               <a:t>Click to edit Master title style</a:t>
             </a:r>
-            <a:endParaRPr lang="en-US"/>
           </a:p>
         </p:txBody>
       </p:sp>
@@ -3746,7 +3659,7 @@
           <a:p>
             <a:pPr lvl="0"/>
             <a:r>
-              <a:rPr lang="en-US" smtClean="0"/>
+              <a:rPr lang="en-US"/>
               <a:t>Click to edit Master text styles</a:t>
             </a:r>
           </a:p>
@@ -3802,38 +3715,37 @@
           <a:p>
             <a:pPr lvl="0"/>
             <a:r>
-              <a:rPr lang="en-US" smtClean="0"/>
+              <a:rPr lang="en-US"/>
               <a:t>Click to edit Master text styles</a:t>
             </a:r>
           </a:p>
           <a:p>
             <a:pPr lvl="1"/>
             <a:r>
-              <a:rPr lang="en-US" smtClean="0"/>
+              <a:rPr lang="en-US"/>
               <a:t>Second level</a:t>
             </a:r>
           </a:p>
           <a:p>
             <a:pPr lvl="2"/>
             <a:r>
-              <a:rPr lang="en-US" smtClean="0"/>
+              <a:rPr lang="en-US"/>
               <a:t>Third level</a:t>
             </a:r>
           </a:p>
           <a:p>
             <a:pPr lvl="3"/>
             <a:r>
-              <a:rPr lang="en-US" smtClean="0"/>
+              <a:rPr lang="en-US"/>
               <a:t>Fourth level</a:t>
             </a:r>
           </a:p>
           <a:p>
             <a:pPr lvl="4"/>
             <a:r>
-              <a:rPr lang="en-US" smtClean="0"/>
+              <a:rPr lang="en-US"/>
               <a:t>Fifth level</a:t>
             </a:r>
-            <a:endParaRPr lang="en-US"/>
           </a:p>
         </p:txBody>
       </p:sp>
@@ -3896,7 +3808,7 @@
           <a:p>
             <a:pPr lvl="0"/>
             <a:r>
-              <a:rPr lang="en-US" smtClean="0"/>
+              <a:rPr lang="en-US"/>
               <a:t>Click to edit Master text styles</a:t>
             </a:r>
           </a:p>
@@ -3952,38 +3864,37 @@
           <a:p>
             <a:pPr lvl="0"/>
             <a:r>
-              <a:rPr lang="en-US" smtClean="0"/>
+              <a:rPr lang="en-US"/>
               <a:t>Click to edit Master text styles</a:t>
             </a:r>
           </a:p>
           <a:p>
             <a:pPr lvl="1"/>
             <a:r>
-              <a:rPr lang="en-US" smtClean="0"/>
+              <a:rPr lang="en-US"/>
               <a:t>Second level</a:t>
             </a:r>
           </a:p>
           <a:p>
             <a:pPr lvl="2"/>
             <a:r>
-              <a:rPr lang="en-US" smtClean="0"/>
+              <a:rPr lang="en-US"/>
               <a:t>Third level</a:t>
             </a:r>
           </a:p>
           <a:p>
             <a:pPr lvl="3"/>
             <a:r>
-              <a:rPr lang="en-US" smtClean="0"/>
+              <a:rPr lang="en-US"/>
               <a:t>Fourth level</a:t>
             </a:r>
           </a:p>
           <a:p>
             <a:pPr lvl="4"/>
             <a:r>
-              <a:rPr lang="en-US" smtClean="0"/>
+              <a:rPr lang="en-US"/>
               <a:t>Fifth level</a:t>
             </a:r>
-            <a:endParaRPr lang="en-US"/>
           </a:p>
         </p:txBody>
       </p:sp>
@@ -4004,7 +3915,7 @@
           <a:p>
             <a:fld id="{5BCAD085-E8A6-8845-BD4E-CB4CCA059FC4}" type="datetimeFigureOut">
               <a:rPr lang="en-US" smtClean="0"/>
-              <a:t>1/27/13</a:t>
+              <a:t>10/28/2026</a:t>
             </a:fld>
             <a:endParaRPr lang="en-US"/>
           </a:p>
@@ -4046,7 +3957,7 @@
           <a:p>
             <a:fld id="{C1FF6DA9-008F-8B48-92A6-B652298478BF}" type="slidenum">
               <a:rPr lang="en-US" smtClean="0"/>
-              <a:t>‹#›</a:t>
+              <a:t>‹N›</a:t>
             </a:fld>
             <a:endParaRPr lang="en-US"/>
           </a:p>
@@ -4098,10 +4009,9 @@
           <a:lstStyle/>
           <a:p>
             <a:r>
-              <a:rPr lang="en-US" smtClean="0"/>
+              <a:rPr lang="en-US"/>
               <a:t>Click to edit Master title style</a:t>
             </a:r>
-            <a:endParaRPr lang="en-US"/>
           </a:p>
         </p:txBody>
       </p:sp>
@@ -4122,7 +4032,7 @@
           <a:p>
             <a:fld id="{5BCAD085-E8A6-8845-BD4E-CB4CCA059FC4}" type="datetimeFigureOut">
               <a:rPr lang="en-US" smtClean="0"/>
-              <a:t>1/27/13</a:t>
+              <a:t>10/28/2026</a:t>
             </a:fld>
             <a:endParaRPr lang="en-US"/>
           </a:p>
@@ -4164,7 +4074,7 @@
           <a:p>
             <a:fld id="{C1FF6DA9-008F-8B48-92A6-B652298478BF}" type="slidenum">
               <a:rPr lang="en-US" smtClean="0"/>
-              <a:t>‹#›</a:t>
+              <a:t>‹N›</a:t>
             </a:fld>
             <a:endParaRPr lang="en-US"/>
           </a:p>
@@ -4217,7 +4127,7 @@
           <a:p>
             <a:fld id="{5BCAD085-E8A6-8845-BD4E-CB4CCA059FC4}" type="datetimeFigureOut">
               <a:rPr lang="en-US" smtClean="0"/>
-              <a:t>1/27/13</a:t>
+              <a:t>10/28/2026</a:t>
             </a:fld>
             <a:endParaRPr lang="en-US"/>
           </a:p>
@@ -4259,7 +4169,7 @@
           <a:p>
             <a:fld id="{C1FF6DA9-008F-8B48-92A6-B652298478BF}" type="slidenum">
               <a:rPr lang="en-US" smtClean="0"/>
-              <a:t>‹#›</a:t>
+              <a:t>‹N›</a:t>
             </a:fld>
             <a:endParaRPr lang="en-US"/>
           </a:p>
@@ -4320,10 +4230,9 @@
           </a:lstStyle>
           <a:p>
             <a:r>
-              <a:rPr lang="en-US" smtClean="0"/>
+              <a:rPr lang="en-US"/>
               <a:t>Click to edit Master title style</a:t>
             </a:r>
-            <a:endParaRPr lang="en-US"/>
           </a:p>
         </p:txBody>
       </p:sp>
@@ -4377,38 +4286,37 @@
           <a:p>
             <a:pPr lvl="0"/>
             <a:r>
-              <a:rPr lang="en-US" smtClean="0"/>
+              <a:rPr lang="en-US"/>
               <a:t>Click to edit Master text styles</a:t>
             </a:r>
           </a:p>
           <a:p>
             <a:pPr lvl="1"/>
             <a:r>
-              <a:rPr lang="en-US" smtClean="0"/>
+              <a:rPr lang="en-US"/>
               <a:t>Second level</a:t>
             </a:r>
           </a:p>
           <a:p>
             <a:pPr lvl="2"/>
             <a:r>
-              <a:rPr lang="en-US" smtClean="0"/>
+              <a:rPr lang="en-US"/>
               <a:t>Third level</a:t>
             </a:r>
           </a:p>
           <a:p>
             <a:pPr lvl="3"/>
             <a:r>
-              <a:rPr lang="en-US" smtClean="0"/>
+              <a:rPr lang="en-US"/>
               <a:t>Fourth level</a:t>
             </a:r>
           </a:p>
           <a:p>
             <a:pPr lvl="4"/>
             <a:r>
-              <a:rPr lang="en-US" smtClean="0"/>
+              <a:rPr lang="en-US"/>
               <a:t>Fifth level</a:t>
             </a:r>
-            <a:endParaRPr lang="en-US"/>
           </a:p>
         </p:txBody>
       </p:sp>
@@ -4471,7 +4379,7 @@
           <a:p>
             <a:pPr lvl="0"/>
             <a:r>
-              <a:rPr lang="en-US" smtClean="0"/>
+              <a:rPr lang="en-US"/>
               <a:t>Click to edit Master text styles</a:t>
             </a:r>
           </a:p>
@@ -4494,7 +4402,7 @@
           <a:p>
             <a:fld id="{5BCAD085-E8A6-8845-BD4E-CB4CCA059FC4}" type="datetimeFigureOut">
               <a:rPr lang="en-US" smtClean="0"/>
-              <a:t>1/27/13</a:t>
+              <a:t>10/28/2026</a:t>
             </a:fld>
             <a:endParaRPr lang="en-US"/>
           </a:p>
@@ -4536,7 +4444,7 @@
           <a:p>
             <a:fld id="{C1FF6DA9-008F-8B48-92A6-B652298478BF}" type="slidenum">
               <a:rPr lang="en-US" smtClean="0"/>
-              <a:t>‹#›</a:t>
+              <a:t>‹N›</a:t>
             </a:fld>
             <a:endParaRPr lang="en-US"/>
           </a:p>
@@ -4597,10 +4505,9 @@
           </a:lstStyle>
           <a:p>
             <a:r>
-              <a:rPr lang="en-US" smtClean="0"/>
+              <a:rPr lang="en-US"/>
               <a:t>Click to edit Master title style</a:t>
             </a:r>
-            <a:endParaRPr lang="en-US"/>
           </a:p>
         </p:txBody>
       </p:sp>
@@ -4724,7 +4631,7 @@
           <a:p>
             <a:pPr lvl="0"/>
             <a:r>
-              <a:rPr lang="en-US" smtClean="0"/>
+              <a:rPr lang="en-US"/>
               <a:t>Click to edit Master text styles</a:t>
             </a:r>
           </a:p>
@@ -4747,7 +4654,7 @@
           <a:p>
             <a:fld id="{5BCAD085-E8A6-8845-BD4E-CB4CCA059FC4}" type="datetimeFigureOut">
               <a:rPr lang="en-US" smtClean="0"/>
-              <a:t>1/27/13</a:t>
+              <a:t>10/28/2026</a:t>
             </a:fld>
             <a:endParaRPr lang="en-US"/>
           </a:p>
@@ -4789,7 +4696,7 @@
           <a:p>
             <a:fld id="{C1FF6DA9-008F-8B48-92A6-B652298478BF}" type="slidenum">
               <a:rPr lang="en-US" smtClean="0"/>
-              <a:t>‹#›</a:t>
+              <a:t>‹N›</a:t>
             </a:fld>
             <a:endParaRPr lang="en-US"/>
           </a:p>
@@ -4856,10 +4763,9 @@
           <a:lstStyle/>
           <a:p>
             <a:r>
-              <a:rPr lang="en-US" smtClean="0"/>
+              <a:rPr lang="en-US"/>
               <a:t>Click to edit Master title style</a:t>
             </a:r>
-            <a:endParaRPr lang="en-US"/>
           </a:p>
         </p:txBody>
       </p:sp>
@@ -4890,38 +4796,37 @@
           <a:p>
             <a:pPr lvl="0"/>
             <a:r>
-              <a:rPr lang="en-US" smtClean="0"/>
+              <a:rPr lang="en-US"/>
               <a:t>Click to edit Master text styles</a:t>
             </a:r>
           </a:p>
           <a:p>
             <a:pPr lvl="1"/>
             <a:r>
-              <a:rPr lang="en-US" smtClean="0"/>
+              <a:rPr lang="en-US"/>
               <a:t>Second level</a:t>
             </a:r>
           </a:p>
           <a:p>
             <a:pPr lvl="2"/>
             <a:r>
-              <a:rPr lang="en-US" smtClean="0"/>
+              <a:rPr lang="en-US"/>
               <a:t>Third level</a:t>
             </a:r>
           </a:p>
           <a:p>
             <a:pPr lvl="3"/>
             <a:r>
-              <a:rPr lang="en-US" smtClean="0"/>
+              <a:rPr lang="en-US"/>
               <a:t>Fourth level</a:t>
             </a:r>
           </a:p>
           <a:p>
             <a:pPr lvl="4"/>
             <a:r>
-              <a:rPr lang="en-US" smtClean="0"/>
+              <a:rPr lang="en-US"/>
               <a:t>Fifth level</a:t>
             </a:r>
-            <a:endParaRPr lang="en-US"/>
           </a:p>
         </p:txBody>
       </p:sp>
@@ -4960,7 +4865,7 @@
           <a:p>
             <a:fld id="{5BCAD085-E8A6-8845-BD4E-CB4CCA059FC4}" type="datetimeFigureOut">
               <a:rPr lang="en-US" smtClean="0"/>
-              <a:t>1/27/13</a:t>
+              <a:t>10/28/2026</a:t>
             </a:fld>
             <a:endParaRPr lang="en-US"/>
           </a:p>
@@ -5038,7 +4943,7 @@
           <a:p>
             <a:fld id="{C1FF6DA9-008F-8B48-92A6-B652298478BF}" type="slidenum">
               <a:rPr lang="en-US" smtClean="0"/>
-              <a:t>‹#›</a:t>
+              <a:t>‹N›</a:t>
             </a:fld>
             <a:endParaRPr lang="en-US"/>
           </a:p>
@@ -5319,7 +5224,7 @@
 </file>
 
 <file path=ppt/slides/slide1.xml><?xml version="1.0" encoding="utf-8"?>
-<p:sld xmlns:a="http://schemas.openxmlformats.org/drawingml/2006/main" xmlns:p="http://schemas.openxmlformats.org/presentationml/2006/main" xmlns:r="http://schemas.openxmlformats.org/officeDocument/2006/relationships">
+<p:sld xmlns:a="http://schemas.openxmlformats.org/drawingml/2006/main" xmlns:r="http://schemas.openxmlformats.org/officeDocument/2006/relationships" xmlns:p="http://schemas.openxmlformats.org/presentationml/2006/main">
   <p:cSld>
     <p:spTree>
       <p:nvGrpSpPr>
@@ -5327,7 +5232,14 @@
         <p:cNvGrpSpPr/>
         <p:nvPr/>
       </p:nvGrpSpPr>
-      <p:grpSpPr/>
+      <p:grpSpPr>
+        <a:xfrm>
+          <a:off x="0" y="0"/>
+          <a:ext cx="0" cy="0"/>
+          <a:chOff x="0" y="0"/>
+          <a:chExt cx="0" cy="0"/>
+        </a:xfrm>
+      </p:grpSpPr>
       <p:pic>
         <p:nvPicPr>
           <p:cNvPr id="2" name="Picture 1" descr="01_cover.png"/>
@@ -5337,7 +5249,7 @@
           <p:nvPr/>
         </p:nvPicPr>
         <p:blipFill>
-          <a:blip r:embed="rId2"/>
+          <a:blip r:embed="rId3"/>
           <a:stretch>
             <a:fillRect/>
           </a:stretch>
@@ -5361,7 +5273,7 @@
 </file>
 
 <file path=ppt/slides/slide10.xml><?xml version="1.0" encoding="utf-8"?>
-<p:sld xmlns:a="http://schemas.openxmlformats.org/drawingml/2006/main" xmlns:p="http://schemas.openxmlformats.org/presentationml/2006/main" xmlns:r="http://schemas.openxmlformats.org/officeDocument/2006/relationships">
+<p:sld xmlns:a="http://schemas.openxmlformats.org/drawingml/2006/main" xmlns:r="http://schemas.openxmlformats.org/officeDocument/2006/relationships" xmlns:p="http://schemas.openxmlformats.org/presentationml/2006/main">
   <p:cSld>
     <p:spTree>
       <p:nvGrpSpPr>
@@ -5369,7 +5281,14 @@
         <p:cNvGrpSpPr/>
         <p:nvPr/>
       </p:nvGrpSpPr>
-      <p:grpSpPr/>
+      <p:grpSpPr>
+        <a:xfrm>
+          <a:off x="0" y="0"/>
+          <a:ext cx="0" cy="0"/>
+          <a:chOff x="0" y="0"/>
+          <a:chExt cx="0" cy="0"/>
+        </a:xfrm>
+      </p:grpSpPr>
       <p:pic>
         <p:nvPicPr>
           <p:cNvPr id="2" name="Picture 1" descr="10_decisioni.png"/>
@@ -5379,7 +5298,7 @@
           <p:nvPr/>
         </p:nvPicPr>
         <p:blipFill>
-          <a:blip r:embed="rId2"/>
+          <a:blip r:embed="rId3"/>
           <a:stretch>
             <a:fillRect/>
           </a:stretch>
@@ -5403,7 +5322,7 @@
 </file>
 
 <file path=ppt/slides/slide11.xml><?xml version="1.0" encoding="utf-8"?>
-<p:sld xmlns:a="http://schemas.openxmlformats.org/drawingml/2006/main" xmlns:p="http://schemas.openxmlformats.org/presentationml/2006/main" xmlns:r="http://schemas.openxmlformats.org/officeDocument/2006/relationships">
+<p:sld xmlns:a="http://schemas.openxmlformats.org/drawingml/2006/main" xmlns:r="http://schemas.openxmlformats.org/officeDocument/2006/relationships" xmlns:p="http://schemas.openxmlformats.org/presentationml/2006/main">
   <p:cSld>
     <p:spTree>
       <p:nvGrpSpPr>
@@ -5411,7 +5330,14 @@
         <p:cNvGrpSpPr/>
         <p:nvPr/>
       </p:nvGrpSpPr>
-      <p:grpSpPr/>
+      <p:grpSpPr>
+        <a:xfrm>
+          <a:off x="0" y="0"/>
+          <a:ext cx="0" cy="0"/>
+          <a:chOff x="0" y="0"/>
+          <a:chExt cx="0" cy="0"/>
+        </a:xfrm>
+      </p:grpSpPr>
       <p:pic>
         <p:nvPicPr>
           <p:cNvPr id="2" name="Picture 1" descr="11_nfr.png"/>
@@ -5421,7 +5347,7 @@
           <p:nvPr/>
         </p:nvPicPr>
         <p:blipFill>
-          <a:blip r:embed="rId2"/>
+          <a:blip r:embed="rId3"/>
           <a:stretch>
             <a:fillRect/>
           </a:stretch>
@@ -5445,7 +5371,7 @@
 </file>
 
 <file path=ppt/slides/slide12.xml><?xml version="1.0" encoding="utf-8"?>
-<p:sld xmlns:a="http://schemas.openxmlformats.org/drawingml/2006/main" xmlns:p="http://schemas.openxmlformats.org/presentationml/2006/main" xmlns:r="http://schemas.openxmlformats.org/officeDocument/2006/relationships">
+<p:sld xmlns:a="http://schemas.openxmlformats.org/drawingml/2006/main" xmlns:r="http://schemas.openxmlformats.org/officeDocument/2006/relationships" xmlns:p="http://schemas.openxmlformats.org/presentationml/2006/main">
   <p:cSld>
     <p:spTree>
       <p:nvGrpSpPr>
@@ -5453,7 +5379,14 @@
         <p:cNvGrpSpPr/>
         <p:nvPr/>
       </p:nvGrpSpPr>
-      <p:grpSpPr/>
+      <p:grpSpPr>
+        <a:xfrm>
+          <a:off x="0" y="0"/>
+          <a:ext cx="0" cy="0"/>
+          <a:chOff x="0" y="0"/>
+          <a:chExt cx="0" cy="0"/>
+        </a:xfrm>
+      </p:grpSpPr>
       <p:pic>
         <p:nvPicPr>
           <p:cNvPr id="2" name="Picture 1" descr="12_vincoli.png"/>
@@ -5463,7 +5396,7 @@
           <p:nvPr/>
         </p:nvPicPr>
         <p:blipFill>
-          <a:blip r:embed="rId2"/>
+          <a:blip r:embed="rId3"/>
           <a:stretch>
             <a:fillRect/>
           </a:stretch>
@@ -5487,7 +5420,7 @@
 </file>
 
 <file path=ppt/slides/slide13.xml><?xml version="1.0" encoding="utf-8"?>
-<p:sld xmlns:a="http://schemas.openxmlformats.org/drawingml/2006/main" xmlns:p="http://schemas.openxmlformats.org/presentationml/2006/main" xmlns:r="http://schemas.openxmlformats.org/officeDocument/2006/relationships">
+<p:sld xmlns:a="http://schemas.openxmlformats.org/drawingml/2006/main" xmlns:r="http://schemas.openxmlformats.org/officeDocument/2006/relationships" xmlns:p="http://schemas.openxmlformats.org/presentationml/2006/main">
   <p:cSld>
     <p:spTree>
       <p:nvGrpSpPr>
@@ -5495,7 +5428,14 @@
         <p:cNvGrpSpPr/>
         <p:nvPr/>
       </p:nvGrpSpPr>
-      <p:grpSpPr/>
+      <p:grpSpPr>
+        <a:xfrm>
+          <a:off x="0" y="0"/>
+          <a:ext cx="0" cy="0"/>
+          <a:chOff x="0" y="0"/>
+          <a:chExt cx="0" cy="0"/>
+        </a:xfrm>
+      </p:grpSpPr>
       <p:pic>
         <p:nvPicPr>
           <p:cNvPr id="2" name="Picture 1" descr="13_carico.png"/>
@@ -5505,7 +5445,7 @@
           <p:nvPr/>
         </p:nvPicPr>
         <p:blipFill>
-          <a:blip r:embed="rId2"/>
+          <a:blip r:embed="rId3"/>
           <a:stretch>
             <a:fillRect/>
           </a:stretch>
@@ -5529,7 +5469,7 @@
 </file>
 
 <file path=ppt/slides/slide14.xml><?xml version="1.0" encoding="utf-8"?>
-<p:sld xmlns:a="http://schemas.openxmlformats.org/drawingml/2006/main" xmlns:p="http://schemas.openxmlformats.org/presentationml/2006/main" xmlns:r="http://schemas.openxmlformats.org/officeDocument/2006/relationships">
+<p:sld xmlns:a="http://schemas.openxmlformats.org/drawingml/2006/main" xmlns:r="http://schemas.openxmlformats.org/officeDocument/2006/relationships" xmlns:p="http://schemas.openxmlformats.org/presentationml/2006/main">
   <p:cSld>
     <p:spTree>
       <p:nvGrpSpPr>
@@ -5537,7 +5477,14 @@
         <p:cNvGrpSpPr/>
         <p:nvPr/>
       </p:nvGrpSpPr>
-      <p:grpSpPr/>
+      <p:grpSpPr>
+        <a:xfrm>
+          <a:off x="0" y="0"/>
+          <a:ext cx="0" cy="0"/>
+          <a:chOff x="0" y="0"/>
+          <a:chExt cx="0" cy="0"/>
+        </a:xfrm>
+      </p:grpSpPr>
       <p:pic>
         <p:nvPicPr>
           <p:cNvPr id="2" name="Picture 1" descr="14_tecnologie.png"/>
@@ -5547,7 +5494,7 @@
           <p:nvPr/>
         </p:nvPicPr>
         <p:blipFill>
-          <a:blip r:embed="rId2"/>
+          <a:blip r:embed="rId3"/>
           <a:stretch>
             <a:fillRect/>
           </a:stretch>
@@ -5571,7 +5518,7 @@
 </file>
 
 <file path=ppt/slides/slide15.xml><?xml version="1.0" encoding="utf-8"?>
-<p:sld xmlns:a="http://schemas.openxmlformats.org/drawingml/2006/main" xmlns:p="http://schemas.openxmlformats.org/presentationml/2006/main" xmlns:r="http://schemas.openxmlformats.org/officeDocument/2006/relationships">
+<p:sld xmlns:a="http://schemas.openxmlformats.org/drawingml/2006/main" xmlns:r="http://schemas.openxmlformats.org/officeDocument/2006/relationships" xmlns:p="http://schemas.openxmlformats.org/presentationml/2006/main">
   <p:cSld>
     <p:spTree>
       <p:nvGrpSpPr>
@@ -5579,7 +5526,14 @@
         <p:cNvGrpSpPr/>
         <p:nvPr/>
       </p:nvGrpSpPr>
-      <p:grpSpPr/>
+      <p:grpSpPr>
+        <a:xfrm>
+          <a:off x="0" y="0"/>
+          <a:ext cx="0" cy="0"/>
+          <a:chOff x="0" y="0"/>
+          <a:chExt cx="0" cy="0"/>
+        </a:xfrm>
+      </p:grpSpPr>
       <p:pic>
         <p:nvPicPr>
           <p:cNvPr id="2" name="Picture 1" descr="15_architettura.png"/>
@@ -5589,7 +5543,7 @@
           <p:nvPr/>
         </p:nvPicPr>
         <p:blipFill>
-          <a:blip r:embed="rId2"/>
+          <a:blip r:embed="rId3"/>
           <a:stretch>
             <a:fillRect/>
           </a:stretch>
@@ -5613,7 +5567,7 @@
 </file>
 
 <file path=ppt/slides/slide16.xml><?xml version="1.0" encoding="utf-8"?>
-<p:sld xmlns:a="http://schemas.openxmlformats.org/drawingml/2006/main" xmlns:p="http://schemas.openxmlformats.org/presentationml/2006/main" xmlns:r="http://schemas.openxmlformats.org/officeDocument/2006/relationships">
+<p:sld xmlns:a="http://schemas.openxmlformats.org/drawingml/2006/main" xmlns:r="http://schemas.openxmlformats.org/officeDocument/2006/relationships" xmlns:p="http://schemas.openxmlformats.org/presentationml/2006/main">
   <p:cSld>
     <p:spTree>
       <p:nvGrpSpPr>
@@ -5621,7 +5575,14 @@
         <p:cNvGrpSpPr/>
         <p:nvPr/>
       </p:nvGrpSpPr>
-      <p:grpSpPr/>
+      <p:grpSpPr>
+        <a:xfrm>
+          <a:off x="0" y="0"/>
+          <a:ext cx="0" cy="0"/>
+          <a:chOff x="0" y="0"/>
+          <a:chExt cx="0" cy="0"/>
+        </a:xfrm>
+      </p:grpSpPr>
       <p:pic>
         <p:nvPicPr>
           <p:cNvPr id="2" name="Picture 1" descr="16_checklist.png"/>
@@ -5631,7 +5592,7 @@
           <p:nvPr/>
         </p:nvPicPr>
         <p:blipFill>
-          <a:blip r:embed="rId2"/>
+          <a:blip r:embed="rId3"/>
           <a:stretch>
             <a:fillRect/>
           </a:stretch>
@@ -5655,7 +5616,7 @@
 </file>
 
 <file path=ppt/slides/slide17.xml><?xml version="1.0" encoding="utf-8"?>
-<p:sld xmlns:a="http://schemas.openxmlformats.org/drawingml/2006/main" xmlns:p="http://schemas.openxmlformats.org/presentationml/2006/main" xmlns:r="http://schemas.openxmlformats.org/officeDocument/2006/relationships">
+<p:sld xmlns:a="http://schemas.openxmlformats.org/drawingml/2006/main" xmlns:r="http://schemas.openxmlformats.org/officeDocument/2006/relationships" xmlns:p="http://schemas.openxmlformats.org/presentationml/2006/main">
   <p:cSld>
     <p:spTree>
       <p:nvGrpSpPr>
@@ -5663,7 +5624,14 @@
         <p:cNvGrpSpPr/>
         <p:nvPr/>
       </p:nvGrpSpPr>
-      <p:grpSpPr/>
+      <p:grpSpPr>
+        <a:xfrm>
+          <a:off x="0" y="0"/>
+          <a:ext cx="0" cy="0"/>
+          <a:chOff x="0" y="0"/>
+          <a:chExt cx="0" cy="0"/>
+        </a:xfrm>
+      </p:grpSpPr>
       <p:pic>
         <p:nvPicPr>
           <p:cNvPr id="2" name="Picture 1" descr="17_chiusura.png"/>
@@ -5673,7 +5641,7 @@
           <p:nvPr/>
         </p:nvPicPr>
         <p:blipFill>
-          <a:blip r:embed="rId2"/>
+          <a:blip r:embed="rId3"/>
           <a:stretch>
             <a:fillRect/>
           </a:stretch>
@@ -5697,7 +5665,7 @@
 </file>
 
 <file path=ppt/slides/slide18.xml><?xml version="1.0" encoding="utf-8"?>
-<p:sld xmlns:a="http://schemas.openxmlformats.org/drawingml/2006/main" xmlns:p="http://schemas.openxmlformats.org/presentationml/2006/main" xmlns:r="http://schemas.openxmlformats.org/officeDocument/2006/relationships">
+<p:sld xmlns:a="http://schemas.openxmlformats.org/drawingml/2006/main" xmlns:r="http://schemas.openxmlformats.org/officeDocument/2006/relationships" xmlns:p="http://schemas.openxmlformats.org/presentationml/2006/main">
   <p:cSld>
     <p:spTree>
       <p:nvGrpSpPr>
@@ -5705,7 +5673,14 @@
         <p:cNvGrpSpPr/>
         <p:nvPr/>
       </p:nvGrpSpPr>
-      <p:grpSpPr/>
+      <p:grpSpPr>
+        <a:xfrm>
+          <a:off x="0" y="0"/>
+          <a:ext cx="0" cy="0"/>
+          <a:chOff x="0" y="0"/>
+          <a:chExt cx="0" cy="0"/>
+        </a:xfrm>
+      </p:grpSpPr>
       <p:pic>
         <p:nvPicPr>
           <p:cNvPr id="2" name="Picture 1" descr="18_rischi.png"/>
@@ -5715,7 +5690,7 @@
           <p:nvPr/>
         </p:nvPicPr>
         <p:blipFill>
-          <a:blip r:embed="rId2"/>
+          <a:blip r:embed="rId3"/>
           <a:stretch>
             <a:fillRect/>
           </a:stretch>
@@ -5738,8 +5713,8 @@
 </p:sld>
 </file>
 
-<file path=ppt/slides/slide2.xml><?xml version="1.0" encoding="utf-8"?>
-<p:sld xmlns:a="http://schemas.openxmlformats.org/drawingml/2006/main" xmlns:p="http://schemas.openxmlformats.org/presentationml/2006/main" xmlns:r="http://schemas.openxmlformats.org/officeDocument/2006/relationships">
+<file path=ppt/slides/slide19.xml><?xml version="1.0" encoding="utf-8"?>
+<p:sld xmlns:a="http://schemas.openxmlformats.org/drawingml/2006/main" xmlns:r="http://schemas.openxmlformats.org/officeDocument/2006/relationships" xmlns:p="http://schemas.openxmlformats.org/presentationml/2006/main">
   <p:cSld>
     <p:spTree>
       <p:nvGrpSpPr>
@@ -5747,7 +5722,74 @@
         <p:cNvGrpSpPr/>
         <p:nvPr/>
       </p:nvGrpSpPr>
-      <p:grpSpPr/>
+      <p:grpSpPr>
+        <a:xfrm>
+          <a:off x="0" y="0"/>
+          <a:ext cx="0" cy="0"/>
+          <a:chOff x="0" y="0"/>
+          <a:chExt cx="0" cy="0"/>
+        </a:xfrm>
+      </p:grpSpPr>
+      <p:pic>
+        <p:nvPicPr>
+          <p:cNvPr id="3" name="Immagine 2" descr="Diagramma ER completo del Gestionale Effatà: 37 tabelle in cinque gruppi (persone e accessi, beneficiari e adozioni, vetrina e rendicontazione, soldi, contabilità e sistema), dal capitolo 12.2 del PRD v2.3">
+            <a:extLst>
+              <a:ext uri="{FF2B5EF4-FFF2-40B4-BE49-F238E27FC236}">
+                <a16:creationId xmlns:a16="http://schemas.microsoft.com/office/drawing/2014/main" id="{3521C573-7B6E-4ED6-948D-00195BA39D26}"/>
+              </a:ext>
+            </a:extLst>
+          </p:cNvPr>
+          <p:cNvPicPr>
+            <a:picLocks/>
+          </p:cNvPicPr>
+          <p:nvPr/>
+        </p:nvPicPr>
+        <p:blipFill>
+          <a:blip r:embed="rId3"/>
+          <a:stretch>
+            <a:fillRect/>
+          </a:stretch>
+        </p:blipFill>
+        <p:spPr>
+          <a:xfrm>
+            <a:off x="0" y="0"/>
+            <a:ext cx="12192000" cy="6858000"/>
+          </a:xfrm>
+          <a:prstGeom prst="rect">
+            <a:avLst/>
+          </a:prstGeom>
+        </p:spPr>
+      </p:pic>
+    </p:spTree>
+    <p:extLst>
+      <p:ext uri="{BB962C8B-B14F-4D97-AF65-F5344CB8AC3E}">
+        <p14:creationId xmlns:p14="http://schemas.microsoft.com/office/powerpoint/2010/main" val="4162551752"/>
+      </p:ext>
+    </p:extLst>
+  </p:cSld>
+  <p:clrMapOvr>
+    <a:masterClrMapping/>
+  </p:clrMapOvr>
+</p:sld>
+</file>
+
+<file path=ppt/slides/slide2.xml><?xml version="1.0" encoding="utf-8"?>
+<p:sld xmlns:a="http://schemas.openxmlformats.org/drawingml/2006/main" xmlns:r="http://schemas.openxmlformats.org/officeDocument/2006/relationships" xmlns:p="http://schemas.openxmlformats.org/presentationml/2006/main">
+  <p:cSld>
+    <p:spTree>
+      <p:nvGrpSpPr>
+        <p:cNvPr id="1" name=""/>
+        <p:cNvGrpSpPr/>
+        <p:nvPr/>
+      </p:nvGrpSpPr>
+      <p:grpSpPr>
+        <a:xfrm>
+          <a:off x="0" y="0"/>
+          <a:ext cx="0" cy="0"/>
+          <a:chOff x="0" y="0"/>
+          <a:chExt cx="0" cy="0"/>
+        </a:xfrm>
+      </p:grpSpPr>
       <p:pic>
         <p:nvPicPr>
           <p:cNvPr id="2" name="Picture 1" descr="02_chi.png"/>
@@ -5757,7 +5799,7 @@
           <p:nvPr/>
         </p:nvPicPr>
         <p:blipFill>
-          <a:blip r:embed="rId2"/>
+          <a:blip r:embed="rId3"/>
           <a:stretch>
             <a:fillRect/>
           </a:stretch>
@@ -5781,7 +5823,7 @@
 </file>
 
 <file path=ppt/slides/slide3.xml><?xml version="1.0" encoding="utf-8"?>
-<p:sld xmlns:a="http://schemas.openxmlformats.org/drawingml/2006/main" xmlns:p="http://schemas.openxmlformats.org/presentationml/2006/main" xmlns:r="http://schemas.openxmlformats.org/officeDocument/2006/relationships">
+<p:sld xmlns:a="http://schemas.openxmlformats.org/drawingml/2006/main" xmlns:r="http://schemas.openxmlformats.org/officeDocument/2006/relationships" xmlns:p="http://schemas.openxmlformats.org/presentationml/2006/main">
   <p:cSld>
     <p:spTree>
       <p:nvGrpSpPr>
@@ -5789,7 +5831,14 @@
         <p:cNvGrpSpPr/>
         <p:nvPr/>
       </p:nvGrpSpPr>
-      <p:grpSpPr/>
+      <p:grpSpPr>
+        <a:xfrm>
+          <a:off x="0" y="0"/>
+          <a:ext cx="0" cy="0"/>
+          <a:chOff x="0" y="0"/>
+          <a:chExt cx="0" cy="0"/>
+        </a:xfrm>
+      </p:grpSpPr>
       <p:pic>
         <p:nvPicPr>
           <p:cNvPr id="2" name="Picture 1" descr="03_problema.png"/>
@@ -5799,7 +5848,7 @@
           <p:nvPr/>
         </p:nvPicPr>
         <p:blipFill>
-          <a:blip r:embed="rId2"/>
+          <a:blip r:embed="rId3"/>
           <a:stretch>
             <a:fillRect/>
           </a:stretch>
@@ -5823,7 +5872,7 @@
 </file>
 
 <file path=ppt/slides/slide4.xml><?xml version="1.0" encoding="utf-8"?>
-<p:sld xmlns:a="http://schemas.openxmlformats.org/drawingml/2006/main" xmlns:p="http://schemas.openxmlformats.org/presentationml/2006/main" xmlns:r="http://schemas.openxmlformats.org/officeDocument/2006/relationships">
+<p:sld xmlns:a="http://schemas.openxmlformats.org/drawingml/2006/main" xmlns:r="http://schemas.openxmlformats.org/officeDocument/2006/relationships" xmlns:p="http://schemas.openxmlformats.org/presentationml/2006/main">
   <p:cSld>
     <p:spTree>
       <p:nvGrpSpPr>
@@ -5831,7 +5880,14 @@
         <p:cNvGrpSpPr/>
         <p:nvPr/>
       </p:nvGrpSpPr>
-      <p:grpSpPr/>
+      <p:grpSpPr>
+        <a:xfrm>
+          <a:off x="0" y="0"/>
+          <a:ext cx="0" cy="0"/>
+          <a:chOff x="0" y="0"/>
+          <a:chExt cx="0" cy="0"/>
+        </a:xfrm>
+      </p:grpSpPr>
       <p:pic>
         <p:nvPicPr>
           <p:cNvPr id="2" name="Picture 1" descr="04_perimetro.png"/>
@@ -5841,7 +5897,7 @@
           <p:nvPr/>
         </p:nvPicPr>
         <p:blipFill>
-          <a:blip r:embed="rId2"/>
+          <a:blip r:embed="rId3"/>
           <a:stretch>
             <a:fillRect/>
           </a:stretch>
@@ -5865,7 +5921,7 @@
 </file>
 
 <file path=ppt/slides/slide5.xml><?xml version="1.0" encoding="utf-8"?>
-<p:sld xmlns:a="http://schemas.openxmlformats.org/drawingml/2006/main" xmlns:p="http://schemas.openxmlformats.org/presentationml/2006/main" xmlns:r="http://schemas.openxmlformats.org/officeDocument/2006/relationships">
+<p:sld xmlns:a="http://schemas.openxmlformats.org/drawingml/2006/main" xmlns:r="http://schemas.openxmlformats.org/officeDocument/2006/relationships" xmlns:p="http://schemas.openxmlformats.org/presentationml/2006/main">
   <p:cSld>
     <p:spTree>
       <p:nvGrpSpPr>
@@ -5873,7 +5929,14 @@
         <p:cNvGrpSpPr/>
         <p:nvPr/>
       </p:nvGrpSpPr>
-      <p:grpSpPr/>
+      <p:grpSpPr>
+        <a:xfrm>
+          <a:off x="0" y="0"/>
+          <a:ext cx="0" cy="0"/>
+          <a:chOff x="0" y="0"/>
+          <a:chExt cx="0" cy="0"/>
+        </a:xfrm>
+      </p:grpSpPr>
       <p:pic>
         <p:nvPicPr>
           <p:cNvPr id="2" name="Picture 1" descr="05_stakeholder.png"/>
@@ -5883,7 +5946,7 @@
           <p:nvPr/>
         </p:nvPicPr>
         <p:blipFill>
-          <a:blip r:embed="rId2"/>
+          <a:blip r:embed="rId3"/>
           <a:stretch>
             <a:fillRect/>
           </a:stretch>
@@ -5907,7 +5970,7 @@
 </file>
 
 <file path=ppt/slides/slide6.xml><?xml version="1.0" encoding="utf-8"?>
-<p:sld xmlns:a="http://schemas.openxmlformats.org/drawingml/2006/main" xmlns:p="http://schemas.openxmlformats.org/presentationml/2006/main" xmlns:r="http://schemas.openxmlformats.org/officeDocument/2006/relationships">
+<p:sld xmlns:a="http://schemas.openxmlformats.org/drawingml/2006/main" xmlns:r="http://schemas.openxmlformats.org/officeDocument/2006/relationships" xmlns:p="http://schemas.openxmlformats.org/presentationml/2006/main">
   <p:cSld>
     <p:spTree>
       <p:nvGrpSpPr>
@@ -5915,7 +5978,14 @@
         <p:cNvGrpSpPr/>
         <p:nvPr/>
       </p:nvGrpSpPr>
-      <p:grpSpPr/>
+      <p:grpSpPr>
+        <a:xfrm>
+          <a:off x="0" y="0"/>
+          <a:ext cx="0" cy="0"/>
+          <a:chOff x="0" y="0"/>
+          <a:chExt cx="0" cy="0"/>
+        </a:xfrm>
+      </p:grpSpPr>
       <p:pic>
         <p:nvPicPr>
           <p:cNvPr id="2" name="Picture 1" descr="06_ruoli.png"/>
@@ -5925,7 +5995,7 @@
           <p:nvPr/>
         </p:nvPicPr>
         <p:blipFill>
-          <a:blip r:embed="rId2"/>
+          <a:blip r:embed="rId3"/>
           <a:stretch>
             <a:fillRect/>
           </a:stretch>
@@ -5949,7 +6019,7 @@
 </file>
 
 <file path=ppt/slides/slide7.xml><?xml version="1.0" encoding="utf-8"?>
-<p:sld xmlns:a="http://schemas.openxmlformats.org/drawingml/2006/main" xmlns:p="http://schemas.openxmlformats.org/presentationml/2006/main" xmlns:r="http://schemas.openxmlformats.org/officeDocument/2006/relationships">
+<p:sld xmlns:a="http://schemas.openxmlformats.org/drawingml/2006/main" xmlns:r="http://schemas.openxmlformats.org/officeDocument/2006/relationships" xmlns:p="http://schemas.openxmlformats.org/presentationml/2006/main">
   <p:cSld>
     <p:spTree>
       <p:nvGrpSpPr>
@@ -5957,7 +6027,14 @@
         <p:cNvGrpSpPr/>
         <p:nvPr/>
       </p:nvGrpSpPr>
-      <p:grpSpPr/>
+      <p:grpSpPr>
+        <a:xfrm>
+          <a:off x="0" y="0"/>
+          <a:ext cx="0" cy="0"/>
+          <a:chOff x="0" y="0"/>
+          <a:chExt cx="0" cy="0"/>
+        </a:xfrm>
+      </p:grpSpPr>
       <p:pic>
         <p:nvPicPr>
           <p:cNvPr id="2" name="Picture 1" descr="07_soluzione.png"/>
@@ -5967,7 +6044,7 @@
           <p:nvPr/>
         </p:nvPicPr>
         <p:blipFill>
-          <a:blip r:embed="rId2"/>
+          <a:blip r:embed="rId3"/>
           <a:stretch>
             <a:fillRect/>
           </a:stretch>
@@ -5991,7 +6068,7 @@
 </file>
 
 <file path=ppt/slides/slide8.xml><?xml version="1.0" encoding="utf-8"?>
-<p:sld xmlns:a="http://schemas.openxmlformats.org/drawingml/2006/main" xmlns:p="http://schemas.openxmlformats.org/presentationml/2006/main" xmlns:r="http://schemas.openxmlformats.org/officeDocument/2006/relationships">
+<p:sld xmlns:a="http://schemas.openxmlformats.org/drawingml/2006/main" xmlns:r="http://schemas.openxmlformats.org/officeDocument/2006/relationships" xmlns:p="http://schemas.openxmlformats.org/presentationml/2006/main">
   <p:cSld>
     <p:spTree>
       <p:nvGrpSpPr>
@@ -5999,7 +6076,14 @@
         <p:cNvGrpSpPr/>
         <p:nvPr/>
       </p:nvGrpSpPr>
-      <p:grpSpPr/>
+      <p:grpSpPr>
+        <a:xfrm>
+          <a:off x="0" y="0"/>
+          <a:ext cx="0" cy="0"/>
+          <a:chOff x="0" y="0"/>
+          <a:chExt cx="0" cy="0"/>
+        </a:xfrm>
+      </p:grpSpPr>
       <p:pic>
         <p:nvPicPr>
           <p:cNvPr id="2" name="Picture 1" descr="08_flusso.png"/>
@@ -6009,7 +6093,7 @@
           <p:nvPr/>
         </p:nvPicPr>
         <p:blipFill>
-          <a:blip r:embed="rId2"/>
+          <a:blip r:embed="rId3"/>
           <a:stretch>
             <a:fillRect/>
           </a:stretch>
@@ -6033,7 +6117,7 @@
 </file>
 
 <file path=ppt/slides/slide9.xml><?xml version="1.0" encoding="utf-8"?>
-<p:sld xmlns:a="http://schemas.openxmlformats.org/drawingml/2006/main" xmlns:p="http://schemas.openxmlformats.org/presentationml/2006/main" xmlns:r="http://schemas.openxmlformats.org/officeDocument/2006/relationships">
+<p:sld xmlns:a="http://schemas.openxmlformats.org/drawingml/2006/main" xmlns:r="http://schemas.openxmlformats.org/officeDocument/2006/relationships" xmlns:p="http://schemas.openxmlformats.org/presentationml/2006/main">
   <p:cSld>
     <p:spTree>
       <p:nvGrpSpPr>
@@ -6041,7 +6125,14 @@
         <p:cNvGrpSpPr/>
         <p:nvPr/>
       </p:nvGrpSpPr>
-      <p:grpSpPr/>
+      <p:grpSpPr>
+        <a:xfrm>
+          <a:off x="0" y="0"/>
+          <a:ext cx="0" cy="0"/>
+          <a:chOff x="0" y="0"/>
+          <a:chExt cx="0" cy="0"/>
+        </a:xfrm>
+      </p:grpSpPr>
       <p:pic>
         <p:nvPicPr>
           <p:cNvPr id="2" name="Picture 1" descr="09_storie.png"/>
@@ -6051,7 +6142,7 @@
           <p:nvPr/>
         </p:nvPicPr>
         <p:blipFill>
-          <a:blip r:embed="rId2"/>
+          <a:blip r:embed="rId3"/>
           <a:stretch>
             <a:fillRect/>
           </a:stretch>
@@ -6395,7 +6486,7 @@
 </file>
 
 <file path=ppt/theme/theme2.xml><?xml version="1.0" encoding="utf-8"?>
-<a:theme xmlns:a="http://schemas.openxmlformats.org/drawingml/2006/main" name="Office Theme">
+<a:theme xmlns:a="http://schemas.openxmlformats.org/drawingml/2006/main" name="Tema di Office">
   <a:themeElements>
     <a:clrScheme name="Office">
       <a:dk1>
@@ -6405,44 +6496,44 @@
         <a:sysClr val="window" lastClr="FFFFFF"/>
       </a:lt1>
       <a:dk2>
-        <a:srgbClr val="1F497D"/>
+        <a:srgbClr val="44546A"/>
       </a:dk2>
       <a:lt2>
-        <a:srgbClr val="EEECE1"/>
+        <a:srgbClr val="E7E6E6"/>
       </a:lt2>
       <a:accent1>
-        <a:srgbClr val="4F81BD"/>
+        <a:srgbClr val="4472C4"/>
       </a:accent1>
       <a:accent2>
-        <a:srgbClr val="C0504D"/>
+        <a:srgbClr val="ED7D31"/>
       </a:accent2>
       <a:accent3>
-        <a:srgbClr val="9BBB59"/>
+        <a:srgbClr val="A5A5A5"/>
       </a:accent3>
       <a:accent4>
-        <a:srgbClr val="8064A2"/>
+        <a:srgbClr val="FFC000"/>
       </a:accent4>
       <a:accent5>
-        <a:srgbClr val="4BACC6"/>
+        <a:srgbClr val="5B9BD5"/>
       </a:accent5>
       <a:accent6>
-        <a:srgbClr val="F79646"/>
+        <a:srgbClr val="70AD47"/>
       </a:accent6>
       <a:hlink>
-        <a:srgbClr val="0000FF"/>
+        <a:srgbClr val="0563C1"/>
       </a:hlink>
       <a:folHlink>
-        <a:srgbClr val="800080"/>
+        <a:srgbClr val="954F72"/>
       </a:folHlink>
     </a:clrScheme>
     <a:fontScheme name="Office">
       <a:majorFont>
-        <a:latin typeface="Calibri"/>
+        <a:latin typeface="Calibri Light" panose="020F0302020204030204"/>
         <a:ea typeface=""/>
         <a:cs typeface=""/>
-        <a:font script="Jpan" typeface="ＭＳ Ｐゴシック"/>
+        <a:font script="Jpan" typeface="游ゴシック Light"/>
         <a:font script="Hang" typeface="맑은 고딕"/>
-        <a:font script="Hans" typeface="宋体"/>
+        <a:font script="Hans" typeface="等线 Light"/>
         <a:font script="Hant" typeface="新細明體"/>
         <a:font script="Arab" typeface="Times New Roman"/>
         <a:font script="Hebr" typeface="Times New Roman"/>
@@ -6470,14 +6561,31 @@
         <a:font script="Viet" typeface="Times New Roman"/>
         <a:font script="Uigh" typeface="Microsoft Uighur"/>
         <a:font script="Geor" typeface="Sylfaen"/>
+        <a:font script="Armn" typeface="Arial"/>
+        <a:font script="Bugi" typeface="Leelawadee UI"/>
+        <a:font script="Bopo" typeface="Microsoft JhengHei"/>
+        <a:font script="Java" typeface="Javanese Text"/>
+        <a:font script="Lisu" typeface="Segoe UI"/>
+        <a:font script="Mymr" typeface="Myanmar Text"/>
+        <a:font script="Nkoo" typeface="Ebrima"/>
+        <a:font script="Olck" typeface="Nirmala UI"/>
+        <a:font script="Osma" typeface="Ebrima"/>
+        <a:font script="Phag" typeface="Phagspa"/>
+        <a:font script="Syrn" typeface="Estrangelo Edessa"/>
+        <a:font script="Syrj" typeface="Estrangelo Edessa"/>
+        <a:font script="Syre" typeface="Estrangelo Edessa"/>
+        <a:font script="Sora" typeface="Nirmala UI"/>
+        <a:font script="Tale" typeface="Microsoft Tai Le"/>
+        <a:font script="Talu" typeface="Microsoft New Tai Lue"/>
+        <a:font script="Tfng" typeface="Ebrima"/>
       </a:majorFont>
       <a:minorFont>
-        <a:latin typeface="Calibri"/>
+        <a:latin typeface="Calibri" panose="020F0502020204030204"/>
         <a:ea typeface=""/>
         <a:cs typeface=""/>
-        <a:font script="Jpan" typeface="ＭＳ Ｐゴシック"/>
+        <a:font script="Jpan" typeface="游ゴシック"/>
         <a:font script="Hang" typeface="맑은 고딕"/>
-        <a:font script="Hans" typeface="宋体"/>
+        <a:font script="Hans" typeface="等线"/>
         <a:font script="Hant" typeface="新細明體"/>
         <a:font script="Arab" typeface="Arial"/>
         <a:font script="Hebr" typeface="Arial"/>
@@ -6505,6 +6613,23 @@
         <a:font script="Viet" typeface="Arial"/>
         <a:font script="Uigh" typeface="Microsoft Uighur"/>
         <a:font script="Geor" typeface="Sylfaen"/>
+        <a:font script="Armn" typeface="Arial"/>
+        <a:font script="Bugi" typeface="Leelawadee UI"/>
+        <a:font script="Bopo" typeface="Microsoft JhengHei"/>
+        <a:font script="Java" typeface="Javanese Text"/>
+        <a:font script="Lisu" typeface="Segoe UI"/>
+        <a:font script="Mymr" typeface="Myanmar Text"/>
+        <a:font script="Nkoo" typeface="Ebrima"/>
+        <a:font script="Olck" typeface="Nirmala UI"/>
+        <a:font script="Osma" typeface="Ebrima"/>
+        <a:font script="Phag" typeface="Phagspa"/>
+        <a:font script="Syrn" typeface="Estrangelo Edessa"/>
+        <a:font script="Syrj" typeface="Estrangelo Edessa"/>
+        <a:font script="Syre" typeface="Estrangelo Edessa"/>
+        <a:font script="Sora" typeface="Nirmala UI"/>
+        <a:font script="Tale" typeface="Microsoft Tai Le"/>
+        <a:font script="Talu" typeface="Microsoft New Tai Lue"/>
+        <a:font script="Tfng" typeface="Ebrima"/>
       </a:minorFont>
     </a:fontScheme>
     <a:fmtScheme name="Office">
@@ -6516,200 +6641,141 @@
           <a:gsLst>
             <a:gs pos="0">
               <a:schemeClr val="phClr">
-                <a:tint val="50000"/>
-                <a:satMod val="300000"/>
+                <a:lumMod val="110000"/>
+                <a:satMod val="105000"/>
+                <a:tint val="67000"/>
               </a:schemeClr>
             </a:gs>
-            <a:gs pos="35000">
+            <a:gs pos="50000">
               <a:schemeClr val="phClr">
-                <a:tint val="37000"/>
-                <a:satMod val="300000"/>
+                <a:lumMod val="105000"/>
+                <a:satMod val="103000"/>
+                <a:tint val="73000"/>
               </a:schemeClr>
             </a:gs>
             <a:gs pos="100000">
               <a:schemeClr val="phClr">
-                <a:tint val="15000"/>
-                <a:satMod val="350000"/>
+                <a:lumMod val="105000"/>
+                <a:satMod val="109000"/>
+                <a:tint val="81000"/>
               </a:schemeClr>
             </a:gs>
           </a:gsLst>
-          <a:lin ang="16200000" scaled="1"/>
+          <a:lin ang="5400000" scaled="0"/>
         </a:gradFill>
         <a:gradFill rotWithShape="1">
           <a:gsLst>
             <a:gs pos="0">
               <a:schemeClr val="phClr">
-                <a:tint val="100000"/>
+                <a:satMod val="103000"/>
+                <a:lumMod val="102000"/>
+                <a:tint val="94000"/>
+              </a:schemeClr>
+            </a:gs>
+            <a:gs pos="50000">
+              <a:schemeClr val="phClr">
+                <a:satMod val="110000"/>
+                <a:lumMod val="100000"/>
                 <a:shade val="100000"/>
-                <a:satMod val="130000"/>
               </a:schemeClr>
             </a:gs>
             <a:gs pos="100000">
               <a:schemeClr val="phClr">
-                <a:tint val="50000"/>
-                <a:shade val="100000"/>
-                <a:satMod val="350000"/>
+                <a:lumMod val="99000"/>
+                <a:satMod val="120000"/>
+                <a:shade val="78000"/>
               </a:schemeClr>
             </a:gs>
           </a:gsLst>
-          <a:lin ang="16200000" scaled="0"/>
+          <a:lin ang="5400000" scaled="0"/>
         </a:gradFill>
       </a:fillStyleLst>
       <a:lnStyleLst>
-        <a:ln w="9525" cap="flat" cmpd="sng" algn="ctr">
-          <a:solidFill>
-            <a:schemeClr val="phClr">
-              <a:shade val="95000"/>
-              <a:satMod val="105000"/>
-            </a:schemeClr>
-          </a:solidFill>
-          <a:prstDash val="solid"/>
-        </a:ln>
-        <a:ln w="25400" cap="flat" cmpd="sng" algn="ctr">
+        <a:ln w="6350" cap="flat" cmpd="sng" algn="ctr">
           <a:solidFill>
             <a:schemeClr val="phClr"/>
           </a:solidFill>
           <a:prstDash val="solid"/>
+          <a:miter lim="800000"/>
         </a:ln>
-        <a:ln w="38100" cap="flat" cmpd="sng" algn="ctr">
+        <a:ln w="12700" cap="flat" cmpd="sng" algn="ctr">
           <a:solidFill>
             <a:schemeClr val="phClr"/>
           </a:solidFill>
           <a:prstDash val="solid"/>
+          <a:miter lim="800000"/>
+        </a:ln>
+        <a:ln w="19050" cap="flat" cmpd="sng" algn="ctr">
+          <a:solidFill>
+            <a:schemeClr val="phClr"/>
+          </a:solidFill>
+          <a:prstDash val="solid"/>
+          <a:miter lim="800000"/>
         </a:ln>
       </a:lnStyleLst>
       <a:effectStyleLst>
         <a:effectStyle>
+          <a:effectLst/>
+        </a:effectStyle>
+        <a:effectStyle>
+          <a:effectLst/>
+        </a:effectStyle>
+        <a:effectStyle>
           <a:effectLst>
-            <a:outerShdw blurRad="40000" dist="20000" dir="5400000" rotWithShape="0">
+            <a:outerShdw blurRad="57150" dist="19050" dir="5400000" algn="ctr" rotWithShape="0">
               <a:srgbClr val="000000">
-                <a:alpha val="38000"/>
+                <a:alpha val="63000"/>
               </a:srgbClr>
             </a:outerShdw>
           </a:effectLst>
-        </a:effectStyle>
-        <a:effectStyle>
-          <a:effectLst>
-            <a:outerShdw blurRad="40000" dist="23000" dir="5400000" rotWithShape="0">
-              <a:srgbClr val="000000">
-                <a:alpha val="35000"/>
-              </a:srgbClr>
-            </a:outerShdw>
-          </a:effectLst>
-        </a:effectStyle>
-        <a:effectStyle>
-          <a:effectLst>
-            <a:outerShdw blurRad="40000" dist="23000" dir="5400000" rotWithShape="0">
-              <a:srgbClr val="000000">
-                <a:alpha val="35000"/>
-              </a:srgbClr>
-            </a:outerShdw>
-          </a:effectLst>
-          <a:scene3d>
-            <a:camera prst="orthographicFront">
-              <a:rot lat="0" lon="0" rev="0"/>
-            </a:camera>
-            <a:lightRig rig="threePt" dir="t">
-              <a:rot lat="0" lon="0" rev="1200000"/>
-            </a:lightRig>
-          </a:scene3d>
-          <a:sp3d>
-            <a:bevelT w="63500" h="25400"/>
-          </a:sp3d>
         </a:effectStyle>
       </a:effectStyleLst>
       <a:bgFillStyleLst>
         <a:solidFill>
           <a:schemeClr val="phClr"/>
         </a:solidFill>
+        <a:solidFill>
+          <a:schemeClr val="phClr">
+            <a:tint val="95000"/>
+            <a:satMod val="170000"/>
+          </a:schemeClr>
+        </a:solidFill>
         <a:gradFill rotWithShape="1">
           <a:gsLst>
             <a:gs pos="0">
               <a:schemeClr val="phClr">
-                <a:tint val="40000"/>
-                <a:satMod val="350000"/>
+                <a:tint val="93000"/>
+                <a:satMod val="150000"/>
+                <a:shade val="98000"/>
+                <a:lumMod val="102000"/>
               </a:schemeClr>
             </a:gs>
-            <a:gs pos="40000">
+            <a:gs pos="50000">
               <a:schemeClr val="phClr">
-                <a:tint val="45000"/>
-                <a:shade val="99000"/>
-                <a:satMod val="350000"/>
+                <a:tint val="98000"/>
+                <a:satMod val="130000"/>
+                <a:shade val="90000"/>
+                <a:lumMod val="103000"/>
               </a:schemeClr>
             </a:gs>
             <a:gs pos="100000">
               <a:schemeClr val="phClr">
-                <a:shade val="20000"/>
-                <a:satMod val="255000"/>
+                <a:shade val="63000"/>
+                <a:satMod val="120000"/>
               </a:schemeClr>
             </a:gs>
           </a:gsLst>
-          <a:path path="circle">
-            <a:fillToRect l="50000" t="-80000" r="50000" b="180000"/>
-          </a:path>
-        </a:gradFill>
-        <a:gradFill rotWithShape="1">
-          <a:gsLst>
-            <a:gs pos="0">
-              <a:schemeClr val="phClr">
-                <a:tint val="80000"/>
-                <a:satMod val="300000"/>
-              </a:schemeClr>
-            </a:gs>
-            <a:gs pos="100000">
-              <a:schemeClr val="phClr">
-                <a:shade val="30000"/>
-                <a:satMod val="200000"/>
-              </a:schemeClr>
-            </a:gs>
-          </a:gsLst>
-          <a:path path="circle">
-            <a:fillToRect l="50000" t="50000" r="50000" b="50000"/>
-          </a:path>
+          <a:lin ang="5400000" scaled="0"/>
         </a:gradFill>
       </a:bgFillStyleLst>
     </a:fmtScheme>
   </a:themeElements>
-  <a:objectDefaults>
-    <a:spDef>
-      <a:spPr/>
-      <a:bodyPr/>
-      <a:lstStyle/>
-      <a:style>
-        <a:lnRef idx="1">
-          <a:schemeClr val="accent1"/>
-        </a:lnRef>
-        <a:fillRef idx="3">
-          <a:schemeClr val="accent1"/>
-        </a:fillRef>
-        <a:effectRef idx="2">
-          <a:schemeClr val="accent1"/>
-        </a:effectRef>
-        <a:fontRef idx="minor">
-          <a:schemeClr val="lt1"/>
-        </a:fontRef>
-      </a:style>
-    </a:spDef>
-    <a:lnDef>
-      <a:spPr/>
-      <a:bodyPr/>
-      <a:lstStyle/>
-      <a:style>
-        <a:lnRef idx="2">
-          <a:schemeClr val="accent1"/>
-        </a:lnRef>
-        <a:fillRef idx="0">
-          <a:schemeClr val="accent1"/>
-        </a:fillRef>
-        <a:effectRef idx="1">
-          <a:schemeClr val="accent1"/>
-        </a:effectRef>
-        <a:fontRef idx="minor">
-          <a:schemeClr val="tx1"/>
-        </a:fontRef>
-      </a:style>
-    </a:lnDef>
-  </a:objectDefaults>
+  <a:objectDefaults/>
   <a:extraClrSchemeLst/>
+  <a:extLst>
+    <a:ext uri="{05A4C25C-085E-4340-85A3-A5531E510DB2}">
+      <thm15:themeFamily xmlns:thm15="http://schemas.microsoft.com/office/thememl/2012/main" name="Office Theme" id="{62F939B6-93AF-4DB8-9C6B-D6C7DFDC589F}" vid="{4A3C46E8-61CC-4603-A589-7422A47A8E4A}"/>
+    </a:ext>
+  </a:extLst>
 </a:theme>
 </file>
</xml_diff>